<commit_message>
Gouvernance par référents, standards ouverts et faits Claude Code vérifiés
- Équipe de 8 ; relecture par les référents : tech pour les skills
  transverses, du domaine pour les skills spécialisés (exemple Solis et
  parallèle Orange dans les notes), sans CODEOWNERS.
- Slide « S'appuyer sur les standards » recentrée sur Agent Skills et
  l'agnosticisme (Agent Plugins retiré, réponse Q&A dans les notes).
- Versions épinglées à jour sur les slides pollen et config globale.
- Faits vérifiés sur Claude Code 2.1.303 : AGENTS.md lu nativement
  seulement sans CLAUDE.md, skills lus dans .claude/skills uniquement.
- Transition Galerie (1 s) et zoom sur les abeilles.
</commit_message>
<xml_diff>
--- a/talks/slides/talk_devfest_skills.pptx
+++ b/talks/slides/talk_devfest_skills.pptx
@@ -1020,7 +1020,7 @@
           <a:lstStyle/>
           <a:p>
             <a:r>
-              <a:t>D'où l'idée : ne pas copier les skills dans chaque projet, mais garder des modules de skills et les importer, comme des dépendances.</a:t>
+              <a:t>D'où l'idée : ne pas copier les skills dans chaque projet, mais garder des modules de skills et les importer, comme des dépendances. Et la factory va accueillir de nouveaux projets après Solis : chacun déclarera les skills d'équipe dont il a besoin, plus ses propres skills spécialisés.</a:t>
             </a:r>
           </a:p>
         </p:txBody>
@@ -1090,7 +1090,7 @@
           <a:lstStyle/>
           <a:p>
             <a:r>
-              <a:t>Agent Skills standardise le skill. Agent Plugins (v1.0, août 2026) standardise le paquet, mais ne lit que skills/&lt;nom&gt;/ : nos domaines skills/&lt;domaine&gt;/&lt;nom&gt;/ y seraient invisibles, et Claude Code garde son propre .claude-plugin/plugin.json. On l'adoptera quand un client qui installe des plugins en aura besoin. La spec ne définit ni installation ni registre : c'est là qu'intervient pollen.</a:t>
+              <a:t>On s'appuie sur des standards ouverts, rien de propre à un outil. Un skill, c'est un dossier avec un SKILL.md : le même fichier est lu par Claude Code, Copilot, Cursor, Codex ou Gemini CLI. pollen le déploie dans .claude/skills et .agents/skills, le dossier commun aux autres agents : Claude Code, lui, ne lit encore que .claude/skills (vérifié sur la v2.1.303), d'où les deux cibles — et dans .github/skills si on veut Copilot : une ligne dans pollen.yaml. Si l'équipe change d'agent demain, les skills restent. AGENTS.md, lui aussi standard, porte le contexte durable du projet ; les conventions vivent dans les skills. Claude Code lit AGENTS.md nativement depuis la v2.1.277, mais seulement quand le repo n'a pas de CLAUDE.md : on garde donc un CLAUDE.md d'une ligne, @AGENTS.md, qui marche dans toutes les sessions et ne fait jamais lire le fichier deux fois. Si on nous parle d'Agent Plugins (le format de paquet, v1.0 en août 2026) : on ne l'utilise pas. Il ne lit que skills/&lt;nom&gt;/, nos domaines y seraient invisibles, et pollen n'en a pas besoin pour déployer.</a:t>
             </a:r>
           </a:p>
         </p:txBody>
@@ -1650,7 +1650,7 @@
           <a:lstStyle/>
           <a:p>
             <a:r>
-              <a:t>War story : un skill Terragrunt référençait run-all, remplacé par run --all. Péremption factuelle, parfaite pour un scan IA. La péremption de jugement — est-ce encore notre convention ? — reste humaine.</a:t>
+              <a:t>War story : un skill Terragrunt référençait run-all, remplacé par run --all. Péremption factuelle, parfaite pour un scan IA. La péremption de jugement — est-ce encore notre convention ? — reste humaine. Qui relit ? Les skills transverses (Docker, CI, IaC, commits…) : les référents tech, Guillaume et moi, qui les avons posés au départ. Un skill spécialisé, comme celui de l'API Solis, est porté par les référents du domaine : Iliass, chercheur, qui implémente une bonne partie des features de Solis, avec Youssef, lead API et produit, et Rafik, entre tech et produit. Des profils tech, spécialisés sur ce sujet, qui en savent plus que nous : on relit avec eux. Chez Orange, notre client, même modèle : les modules transverses sont tenus par les référents tech et l'équipe platform, les repos spécialisés par le référent de leur domaine. Toujours une PR, jamais relue par son seul auteur, et la CI vérifie le mécanique.</a:t>
             </a:r>
           </a:p>
         </p:txBody>
@@ -1860,7 +1860,7 @@
           <a:lstStyle/>
           <a:p>
             <a:r>
-              <a:t>Source : blog Google Cloud « Behind the scenes: how we build, test and scale Google agent skills » (août 2026). Leur CI : lint, vérification des liens, checklists assistées par IA, et surtout les evals. C'est là qu'on n'en est pas encore. Et un owner par skill : nous, on est huit, pas Google. Chez nous, n'importe qui relit une PR de skill, sauf son auteur, et la CI vérifie le mécanique. Petite équipe : la confiance et la CI, pas l'organigramme. Adaptez la gouvernance à votre taille, mais gardez-en une.</a:t>
+              <a:t>Source : blog Google Cloud « Behind the scenes: how we build, test and scale Google agent skills » (août 2026). Leur CI : lint, vérification des liens, checklists assistées par IA, et surtout les evals. C'est là qu'on n'en est pas encore. Et un owner par skill : nous, on est huit, pas Google. Pas d'organigramme, mais ceux qui savent : les référents tech relisent le transverse, les référents d'un domaine portent ses skills spécialisés, et la CI vérifie le mécanique. Adaptez la gouvernance à votre taille, mais gardez-en une.</a:t>
             </a:r>
           </a:p>
         </p:txBody>
@@ -2140,7 +2140,7 @@
           <a:lstStyle/>
           <a:p>
             <a:r>
-              <a:t>Les seniors ont généré le premier backend, les fondations cloud et l'IaC. Avec leur Claude, les autres ont réussi à faire évoluer ces stacks — c'est le côté positif.</a:t>
+              <a:t>Les seniors ont généré le premier backend, les fondations cloud et l'IaC — et, plus tard, les premiers skills transverses. Avec leur Claude, les autres ont réussi à faire évoluer ces stacks — c'est le côté positif.</a:t>
             </a:r>
           </a:p>
         </p:txBody>
@@ -12867,7 +12867,7 @@
                 </a:solidFill>
                 <a:latin typeface="Avenir Next"/>
               </a:rPr>
-              <a:t>Agent Skills : le format SKILL.md (agentskills.io)</a:t>
+              <a:t>Agent Skills : un format ouvert, SKILL.md (agentskills.io)</a:t>
             </a:r>
           </a:p>
         </p:txBody>
@@ -12950,7 +12950,7 @@
                 </a:solidFill>
                 <a:latin typeface="Avenir Next"/>
               </a:rPr>
-              <a:t>Agent Plugins : un format de paquet — plugin.json + skills/</a:t>
+              <a:t>Lu tel quel par Claude Code, Copilot, Cursor, Codex, Gemini CLI…</a:t>
             </a:r>
           </a:p>
         </p:txBody>
@@ -13033,7 +13033,7 @@
                 </a:solidFill>
                 <a:latin typeface="Avenir Next"/>
               </a:rPr>
-              <a:t>Portés par Vercel, Google, Microsoft, OpenAI, AWS, Cursor…</a:t>
+              <a:t>AGENTS.md pour le contexte du projet, SKILL.md pour les conventions</a:t>
             </a:r>
           </a:p>
         </p:txBody>
@@ -13116,14 +13116,97 @@
                 </a:solidFill>
                 <a:latin typeface="Avenir Next"/>
               </a:rPr>
-              <a:t>Ni installeur, ni épinglage : c'est le rôle d'un outil</a:t>
-            </a:r>
-          </a:p>
-        </p:txBody>
-      </p:sp>
-      <p:sp>
-        <p:nvSpPr>
-          <p:cNvPr id="18" name="Rectangle 17"/>
+              <a:t>Vérifié en CI : skill-validator contrôle le format</a:t>
+            </a:r>
+          </a:p>
+        </p:txBody>
+      </p:sp>
+      <p:sp>
+        <p:nvSpPr>
+          <p:cNvPr id="18" name="Hexagon 17"/>
+          <p:cNvSpPr/>
+          <p:nvPr/>
+        </p:nvSpPr>
+        <p:spPr>
+          <a:xfrm>
+            <a:off x="713232" y="4453128"/>
+            <a:ext cx="173736" cy="173736"/>
+          </a:xfrm>
+          <a:prstGeom prst="hexagon">
+            <a:avLst/>
+          </a:prstGeom>
+          <a:solidFill>
+            <a:srgbClr val="00B5FB"/>
+          </a:solidFill>
+          <a:ln>
+            <a:noFill/>
+          </a:ln>
+          <a:effectLst/>
+        </p:spPr>
+        <p:style>
+          <a:lnRef idx="1">
+            <a:schemeClr val="accent1"/>
+          </a:lnRef>
+          <a:fillRef idx="3">
+            <a:schemeClr val="accent1"/>
+          </a:fillRef>
+          <a:effectRef idx="2">
+            <a:schemeClr val="accent1"/>
+          </a:effectRef>
+          <a:fontRef idx="minor">
+            <a:schemeClr val="lt1"/>
+          </a:fontRef>
+        </p:style>
+        <p:txBody>
+          <a:bodyPr rtlCol="0" anchor="ctr"/>
+          <a:lstStyle/>
+          <a:p>
+            <a:pPr algn="ctr"/>
+          </a:p>
+        </p:txBody>
+      </p:sp>
+      <p:sp>
+        <p:nvSpPr>
+          <p:cNvPr id="19" name="TextBox 18"/>
+          <p:cNvSpPr txBox="1"/>
+          <p:nvPr/>
+        </p:nvSpPr>
+        <p:spPr>
+          <a:xfrm>
+            <a:off x="1097280" y="4343400"/>
+            <a:ext cx="10515600" cy="548640"/>
+          </a:xfrm>
+          <a:prstGeom prst="rect">
+            <a:avLst/>
+          </a:prstGeom>
+          <a:noFill/>
+        </p:spPr>
+        <p:txBody>
+          <a:bodyPr wrap="square" lIns="0" rIns="0" tIns="0" bIns="0">
+            <a:spAutoFit/>
+          </a:bodyPr>
+          <a:lstStyle/>
+          <a:p>
+            <a:pPr algn="l">
+              <a:spcAft>
+                <a:spcPts val="0"/>
+              </a:spcAft>
+            </a:pPr>
+            <a:r>
+              <a:rPr sz="2100">
+                <a:solidFill>
+                  <a:srgbClr val="2A2F3A"/>
+                </a:solidFill>
+                <a:latin typeface="Avenir Next"/>
+              </a:rPr>
+              <a:t>Ni installation ni épinglage dans le standard : c'est le rôle de pollen</a:t>
+            </a:r>
+          </a:p>
+        </p:txBody>
+      </p:sp>
+      <p:sp>
+        <p:nvSpPr>
+          <p:cNvPr id="20" name="Rectangle 19"/>
           <p:cNvSpPr/>
           <p:nvPr/>
         </p:nvSpPr>
@@ -13175,7 +13258,7 @@
       </p:sp>
       <p:sp>
         <p:nvSpPr>
-          <p:cNvPr id="19" name="TextBox 18"/>
+          <p:cNvPr id="21" name="TextBox 20"/>
           <p:cNvSpPr txBox="1"/>
           <p:nvPr/>
         </p:nvSpPr>
@@ -13207,14 +13290,14 @@
                 </a:solidFill>
                 <a:latin typeface="Avenir Next"/>
               </a:rPr>
-              <a:t>Agent Skills pour le format. Agent Plugins quand un client en aura besoin.</a:t>
+              <a:t>Écrits une fois, lus par tous les agents : aucun lock-in.</a:t>
             </a:r>
           </a:p>
         </p:txBody>
       </p:sp>
       <p:pic>
         <p:nvPicPr>
-          <p:cNvPr id="20" name="bee.png" descr="bee.png"/>
+          <p:cNvPr id="22" name="bee.png" descr="bee.png"/>
           <p:cNvPicPr>
             <a:picLocks noChangeAspect="1"/>
           </p:cNvPicPr>
@@ -13238,7 +13321,7 @@
       </p:pic>
       <p:pic>
         <p:nvPicPr>
-          <p:cNvPr id="21" name="logo.png" descr="logo.png"/>
+          <p:cNvPr id="23" name="logo.png" descr="logo.png"/>
           <p:cNvPicPr>
             <a:picLocks noChangeAspect="1"/>
           </p:cNvPicPr>
@@ -13262,7 +13345,7 @@
       </p:pic>
       <p:sp>
         <p:nvSpPr>
-          <p:cNvPr id="22" name="TextBox 21"/>
+          <p:cNvPr id="24" name="TextBox 23"/>
           <p:cNvSpPr txBox="1"/>
           <p:nvPr/>
         </p:nvSpPr>
@@ -13353,7 +13436,7 @@
                                           </p:stCondLst>
                                         </p:cTn>
                                         <p:tgtEl>
-                                          <p:spTgt spid="20"/>
+                                          <p:spTgt spid="22"/>
                                         </p:tgtEl>
                                         <p:attrNameLst>
                                           <p:attrName>style.visibility</p:attrName>
@@ -13367,7 +13450,7 @@
                                       <p:cBhvr>
                                         <p:cTn id="7" dur="500" fill="hold"/>
                                         <p:tgtEl>
-                                          <p:spTgt spid="20"/>
+                                          <p:spTgt spid="22"/>
                                         </p:tgtEl>
                                         <p:attrNameLst>
                                           <p:attrName>ppt_w</p:attrName>
@@ -13390,7 +13473,7 @@
                                       <p:cBhvr>
                                         <p:cTn id="8" dur="500" fill="hold"/>
                                         <p:tgtEl>
-                                          <p:spTgt spid="20"/>
+                                          <p:spTgt spid="22"/>
                                         </p:tgtEl>
                                         <p:attrNameLst>
                                           <p:attrName>ppt_h</p:attrName>
@@ -13413,7 +13496,7 @@
                                       <p:cBhvr>
                                         <p:cTn id="9" dur="500"/>
                                         <p:tgtEl>
-                                          <p:spTgt spid="20"/>
+                                          <p:spTgt spid="22"/>
                                         </p:tgtEl>
                                       </p:cBhvr>
                                     </p:animEffect>
@@ -13652,7 +13735,7 @@
                 </a:solidFill>
                 <a:latin typeface="Consolas"/>
               </a:rPr>
-              <a:t>    revision: e674d360…  # v0.2.5</a:t>
+              <a:t>    revision: 351fd495…  # v0.3.1</a:t>
             </a:r>
           </a:p>
           <a:p>
@@ -17072,7 +17155,7 @@
                 </a:solidFill>
                 <a:latin typeface="Consolas"/>
               </a:rPr>
-              <a:t>    revision: e674d360…  # v0.2.5</a:t>
+              <a:t>    revision: 351fd495…  # v0.3.1</a:t>
             </a:r>
           </a:p>
           <a:p>
@@ -17104,7 +17187,7 @@
                 </a:solidFill>
                 <a:latin typeface="Consolas"/>
               </a:rPr>
-              <a:t>    revision: 0233458c…  # v0.2.0</a:t>
+              <a:t>    revision: e4d83514…  # v0.4.0</a:t>
             </a:r>
           </a:p>
           <a:p>
@@ -17136,7 +17219,7 @@
                 </a:solidFill>
                 <a:latin typeface="Consolas"/>
               </a:rPr>
-              <a:t>    revision: acad0f52…  # v0.1.0</a:t>
+              <a:t>    revision: 3a461867…  # v0.1.1</a:t>
             </a:r>
           </a:p>
           <a:p>
@@ -17168,7 +17251,7 @@
                 </a:solidFill>
                 <a:latin typeface="Consolas"/>
               </a:rPr>
-              <a:t>    revision: c49400b8…  # v0.4.0</a:t>
+              <a:t>    revision: c327e7e7…  # v0.5.0</a:t>
             </a:r>
           </a:p>
           <a:p>
@@ -17200,7 +17283,7 @@
                 </a:solidFill>
                 <a:latin typeface="Consolas"/>
               </a:rPr>
-              <a:t>    revision: 5ff0ccf9…  # v0.1.0</a:t>
+              <a:t>    revision: cd21b30d…  # v0.1.1</a:t>
             </a:r>
           </a:p>
         </p:txBody>
@@ -20422,7 +20505,7 @@
                 </a:solidFill>
                 <a:latin typeface="Avenir Next"/>
               </a:rPr>
-              <a:t>Une PR, un relecteur (pas l'auteur), la CI fait le reste</a:t>
+              <a:t>Relecture : référents tech (transverse), référents du domaine (spécialisé)</a:t>
             </a:r>
           </a:p>
         </p:txBody>

</xml_diff>

<commit_message>
Repères de scène en tête des notes de chaque slide, dialogue renuméroté
- CUES dans slides_content.py : qui parle, points clés, phrase de relais,
  indexés par titre de slide et placés au-dessus des notes existantes
- generate_slides.py refuse un repère dont le titre ne correspond à
  aucune slide
- dialogue.md : slide TechCast ajoutée en 3, slides suivantes décalées
</commit_message>
<xml_diff>
--- a/talks/slides/talk_devfest_skills.pptx
+++ b/talks/slides/talk_devfest_skills.pptx
@@ -533,6 +533,27 @@
           <a:lstStyle/>
           <a:p>
             <a:r>
+              <a:t>🎤 Mazlum, puis Guillaume</a:t>
+            </a:r>
+          </a:p>
+          <a:p>
+            <a:r>
+              <a:t>• Générer du code avec une IA : trivial. Comme l'équipe l'attend : autre histoire.</a:t>
+            </a:r>
+          </a:p>
+          <a:p>
+            <a:r>
+              <a:t>↪ Guillaume : « Et c'est cette histoire-là qu'on vient vous raconter. »</a:t>
+            </a:r>
+          </a:p>
+          <a:p/>
+          <a:p>
+            <a:r>
+              <a:t>────────</a:t>
+            </a:r>
+          </a:p>
+          <a:p>
+            <a:r>
               <a:t>Bonjour à tous ! Générer du code avec une IA, aujourd'hui, c'est trivial. Le générer comme votre équipe l'attend, c'est une autre histoire. On va vous raconter comment on s'y est pris chez GroupBees.</a:t>
             </a:r>
           </a:p>
@@ -603,6 +624,32 @@
           <a:lstStyle/>
           <a:p>
             <a:r>
+              <a:t>🎤 Mazlum</a:t>
+            </a:r>
+          </a:p>
+          <a:p>
+            <a:r>
+              <a:t>• Un dossier, un SKILL.md, standard Agent Skills</a:t>
+            </a:r>
+          </a:p>
+          <a:p>
+            <a:r>
+              <a:t>• La description est toujours vue ; le corps, seulement si la tâche correspond</a:t>
+            </a:r>
+          </a:p>
+          <a:p>
+            <a:r>
+              <a:t>↪ Guillaume : « Et un skill, ce n'est pas que du texte. »</a:t>
+            </a:r>
+          </a:p>
+          <a:p/>
+          <a:p>
+            <a:r>
+              <a:t>────────</a:t>
+            </a:r>
+          </a:p>
+          <a:p>
+            <a:r>
               <a:t>Un skill = un dossier, un SKILL.md, le standard ouvert Agent Skills (agentskills.io). La description sert de déclencheur : l'agent la voit en permanence, et ne lit le corps que si la tâche matche. C'est la progressive disclosure. Lu tel quel par Claude Code, Copilot, Cursor, Codex, Antigravity CLI.</a:t>
             </a:r>
           </a:p>
@@ -673,6 +720,27 @@
           <a:lstStyle/>
           <a:p>
             <a:r>
+              <a:t>🎤 Guillaume</a:t>
+            </a:r>
+          </a:p>
+          <a:p>
+            <a:r>
+              <a:t>• references/ : lu à la demande · assets/ : fichiers à copier · scripts/ : contrôles</a:t>
+            </a:r>
+          </a:p>
+          <a:p>
+            <a:r>
+              <a:t>↪ Mazlum : « Ce qui ne veut pas dire qu'on jette le CLAUDE.md. »</a:t>
+            </a:r>
+          </a:p>
+          <a:p/>
+          <a:p>
+            <a:r>
+              <a:t>────────</a:t>
+            </a:r>
+          </a:p>
+          <a:p>
+            <a:r>
               <a:t>Le standard Agent Skills prévoit trois dossiers optionnels à côté du SKILL.md. references/ : de la doc lue à la demande — sur un projet Node, l'agent lit node.md, pas les quatre autres. assets/ : des fichiers complets à copier — le Dockerfile Python, celui qui tourne en prod sur Solis. scripts/ : du code exécuté, jamais chargé dans le contexte — une convention vérifiable devient un script plutôt qu'une phrase. Trois niveaux de chargement : la description toujours, le SKILL.md au déclenchement, le reste seulement si besoin. Notre CI refuse tout autre dossier. → Bascule IDE sur skills-core pour ouvrir ces trois skills.</a:t>
             </a:r>
           </a:p>
@@ -743,6 +811,27 @@
           <a:lstStyle/>
           <a:p>
             <a:r>
+              <a:t>🎤 Mazlum</a:t>
+            </a:r>
+          </a:p>
+          <a:p>
+            <a:r>
+              <a:t>• CLAUDE.md redevient le contexte durable du projet (AGENTS.md + pont d'une ligne)</a:t>
+            </a:r>
+          </a:p>
+          <a:p>
+            <a:r>
+              <a:t>• Les conventions vivent dans les skills</a:t>
+            </a:r>
+          </a:p>
+          <a:p/>
+          <a:p>
+            <a:r>
+              <a:t>────────</a:t>
+            </a:r>
+          </a:p>
+          <a:p>
+            <a:r>
               <a:t>On ne jette pas le CLAUDE.md : il redevient ce qu'il doit être, le contexte durable du projet (chez nous un AGENTS.md + un pont CLAUDE.md). Les conventions, elles, partent dans les skills.</a:t>
             </a:r>
           </a:p>
@@ -813,6 +902,27 @@
           <a:lstStyle/>
           <a:p>
             <a:r>
+              <a:t>🎤 Guillaume</a:t>
+            </a:r>
+          </a:p>
+          <a:p>
+            <a:r>
+              <a:t>• Docker générique + Python par-dessus, qui n'ajoute que le spécifique</a:t>
+            </a:r>
+          </a:p>
+          <a:p>
+            <a:r>
+              <a:t>↪ Mazlum : « Restait à les partager dans l'équipe. »</a:t>
+            </a:r>
+          </a:p>
+          <a:p/>
+          <a:p>
+            <a:r>
+              <a:t>────────</a:t>
+            </a:r>
+          </a:p>
+          <a:p>
+            <a:r>
               <a:t>L'exemple de découpage : docker-image-conventions est agnostique du langage ; python-docker-multistage se compose par-dessus et n'ajoute que le spécifique Python. Même logique direnv / python-uv-direnv. Chaque skill reste petit, et le générique sert aux autres stacks.</a:t>
             </a:r>
           </a:p>
@@ -883,6 +993,22 @@
           <a:lstStyle/>
           <a:p>
             <a:r>
+              <a:t>🎤 Guillaume</a:t>
+            </a:r>
+          </a:p>
+          <a:p>
+            <a:r>
+              <a:t>• Un repo git de skills, synchronisé sur la machine de chaque dev</a:t>
+            </a:r>
+          </a:p>
+          <a:p/>
+          <a:p>
+            <a:r>
+              <a:t>────────</a:t>
+            </a:r>
+          </a:p>
+          <a:p>
+            <a:r>
               <a:t>Il fallait ensuite partager ces skills. Première approche : un catalogue git, synchronisé sur la machine de chaque dev.</a:t>
             </a:r>
           </a:p>
@@ -953,6 +1079,27 @@
           <a:lstStyle/>
           <a:p>
             <a:r>
+              <a:t>🎤 Guillaume</a:t>
+            </a:r>
+          </a:p>
+          <a:p>
+            <a:r>
+              <a:t>• Script → dossiers perso des agents ; plusieurs modules ; version = tag git</a:t>
+            </a:r>
+          </a:p>
+          <a:p>
+            <a:r>
+              <a:t>↪ Mazlum : « … jusqu'à ce que je l'utilise chez un client. »</a:t>
+            </a:r>
+          </a:p>
+          <a:p/>
+          <a:p>
+            <a:r>
+              <a:t>────────</a:t>
+            </a:r>
+          </a:p>
+          <a:p>
+            <a:r>
               <a:t>Un module = un repo git. Le script copie chaque skill dans les répertoires personnels que lisent les outils. Plusieurs modules cohabitent grâce à un ledger par module. Version = tag git.</a:t>
             </a:r>
           </a:p>
@@ -1023,6 +1170,32 @@
           <a:lstStyle/>
           <a:p>
             <a:r>
+              <a:t>🎤 Mazlum</a:t>
+            </a:r>
+          </a:p>
+          <a:p>
+            <a:r>
+              <a:t>• En global, nos règles s'appliquent partout : perso, clients</a:t>
+            </a:r>
+          </a:p>
+          <a:p>
+            <a:r>
+              <a:t>• On veut choisir, projet par projet</a:t>
+            </a:r>
+          </a:p>
+          <a:p>
+            <a:r>
+              <a:t>↪ Guillaume : « Et choisir des skills par projet, c'est gérer des dépendances. »</a:t>
+            </a:r>
+          </a:p>
+          <a:p/>
+          <a:p>
+            <a:r>
+              <a:t>────────</a:t>
+            </a:r>
+          </a:p>
+          <a:p>
+            <a:r>
               <a:t>Chargé en global, ça s'applique tout le temps, même sur nos projets non-GroupBees ou chez un client qui a ses propres règles. Même si ce sont de bonnes pratiques, on veut la flexibilité de choisir.</a:t>
             </a:r>
           </a:p>
@@ -1093,6 +1266,32 @@
           <a:lstStyle/>
           <a:p>
             <a:r>
+              <a:t>🎤 Guillaume</a:t>
+            </a:r>
+          </a:p>
+          <a:p>
+            <a:r>
+              <a:t>• On importe les skills comme des dépendances, + les skills du projet</a:t>
+            </a:r>
+          </a:p>
+          <a:p>
+            <a:r>
+              <a:t>• La factory accueillera d'autres projets que Solis</a:t>
+            </a:r>
+          </a:p>
+          <a:p>
+            <a:r>
+              <a:t>↪ Mazlum : « À une condition : ne rien inventer de propriétaire. »</a:t>
+            </a:r>
+          </a:p>
+          <a:p/>
+          <a:p>
+            <a:r>
+              <a:t>────────</a:t>
+            </a:r>
+          </a:p>
+          <a:p>
+            <a:r>
               <a:t>D'où l'idée : ne pas copier les skills dans chaque projet, mais garder des modules de skills et les importer, comme des dépendances. Et la factory va accueillir de nouveaux projets après Solis : chacun déclarera les skills d'équipe dont il a besoin, plus ses propres skills spécialisés.</a:t>
             </a:r>
           </a:p>
@@ -1163,6 +1362,32 @@
           <a:lstStyle/>
           <a:p>
             <a:r>
+              <a:t>🎤 Mazlum</a:t>
+            </a:r>
+          </a:p>
+          <a:p>
+            <a:r>
+              <a:t>• Agent Skills : Claude Code, Copilot, Cursor, Codex, Antigravity CLI</a:t>
+            </a:r>
+          </a:p>
+          <a:p>
+            <a:r>
+              <a:t>• AGENTS.md pour le contexte ; on change d'agent, les skills restent</a:t>
+            </a:r>
+          </a:p>
+          <a:p>
+            <a:r>
+              <a:t>↪ « Il manquait l'outil pour les installer. Guillaume, raconte-leur pollen. »</a:t>
+            </a:r>
+          </a:p>
+          <a:p/>
+          <a:p>
+            <a:r>
+              <a:t>────────</a:t>
+            </a:r>
+          </a:p>
+          <a:p>
+            <a:r>
               <a:t>On s'appuie sur des standards ouverts, rien de propre à un outil. Un skill, c'est un dossier avec un SKILL.md : le même fichier est lu par Claude Code, Copilot, Cursor, Codex ou Antigravity CLI. pollen le déploie dans .claude/skills et .agents/skills, le dossier commun aux autres agents : Claude Code, lui, ne lit encore que .claude/skills (vérifié sur la v2.1.303), d'où les deux cibles — et dans .github/skills si on veut Copilot : une ligne dans pollen.yaml. Si l'équipe change d'agent demain, les skills restent. AGENTS.md, lui aussi standard, porte le contexte durable du projet ; les conventions vivent dans les skills. Claude Code lit AGENTS.md nativement depuis la v2.1.277, mais seulement quand le repo n'a pas de CLAUDE.md : on garde donc un CLAUDE.md d'une ligne, @AGENTS.md, qui marche dans toutes les sessions et ne fait jamais lire le fichier deux fois. Si on nous parle d'Agent Plugins (le format de paquet, v1.0 en août 2026) : on ne l'utilise pas. Il ne lit que skills/&lt;nom&gt;/, nos domaines y seraient invisibles, et pollen n'en a pas besoin pour déployer.</a:t>
             </a:r>
           </a:p>
@@ -1233,6 +1458,27 @@
           <a:lstStyle/>
           <a:p>
             <a:r>
+              <a:t>🎤 Guillaume</a:t>
+            </a:r>
+          </a:p>
+          <a:p>
+            <a:r>
+              <a:t>• CLI open source en Rust, pollen.yaml façon pre-commit</a:t>
+            </a:r>
+          </a:p>
+          <a:p>
+            <a:r>
+              <a:t>• update : installe, rafraîchit, supprime ce qu'on a retiré</a:t>
+            </a:r>
+          </a:p>
+          <a:p/>
+          <a:p>
+            <a:r>
+              <a:t>────────</a:t>
+            </a:r>
+          </a:p>
+          <a:p>
+            <a:r>
               <a:t>pollen, notre CLI open source (Rust). Syntaxe inspirée de pre-commit : une liste de sources, chacune épinglée. Il installe, rafraîchit ce qui a bougé et supprime ce qu'on a retiré. Sources git — SSH pour les repos privés — ou dossier local. Déployé dans .claude/skills et .agents/skills : tous les agents sont servis.</a:t>
             </a:r>
           </a:p>
@@ -1303,6 +1549,32 @@
           <a:lstStyle/>
           <a:p>
             <a:r>
+              <a:t>🎤 Chacun présente l'autre</a:t>
+            </a:r>
+          </a:p>
+          <a:p>
+            <a:r>
+              <a:t>• Mazlum présente Guillaume (« m'empêche de mettre en prod le vendredi »)</a:t>
+            </a:r>
+          </a:p>
+          <a:p>
+            <a:r>
+              <a:t>• Guillaume présente Mazlum (« écrit les règles… et les oublie dans son Dockerfile »)</a:t>
+            </a:r>
+          </a:p>
+          <a:p>
+            <a:r>
+              <a:t>↪ Mazlum : « C'est exactement le sujet du talk. »</a:t>
+            </a:r>
+          </a:p>
+          <a:p/>
+          <a:p>
+            <a:r>
+              <a:t>────────</a:t>
+            </a:r>
+          </a:p>
+          <a:p>
+            <a:r>
               <a:t>Mazlum : Head of Data chez GroupBees, GDE Cloud et Docker Captain. Guillaume : Platform Engineer &amp; SRE chez GroupBees, fondateur de THEREALM, et formateur à EPITECH et Polytech.</a:t>
             </a:r>
           </a:p>
@@ -1373,6 +1645,32 @@
           <a:lstStyle/>
           <a:p>
             <a:r>
+              <a:t>🎤 Guillaume</a:t>
+            </a:r>
+          </a:p>
+          <a:p>
+            <a:r>
+              <a:t>• Périmètre étroit : déplace des dossiers, valide la spec</a:t>
+            </a:r>
+          </a:p>
+          <a:p>
+            <a:r>
+              <a:t>• Un skill écrit à la main n'est jamais écrasé</a:t>
+            </a:r>
+          </a:p>
+          <a:p>
+            <a:r>
+              <a:t>↪ Mazlum : « Et la question à chaque fois : où est le lockfile ? »</a:t>
+            </a:r>
+          </a:p>
+          <a:p/>
+          <a:p>
+            <a:r>
+              <a:t>────────</a:t>
+            </a:r>
+          </a:p>
+          <a:p>
+            <a:r>
               <a:t>On assume un périmètre étroit : pollen déplace des dossiers qui existent et les valide contre la spec. Son état (.pollen.json) enregistre ce qu'il a installé et quelle config possède le dossier : un skill écrit à la main n'est jamais écrasé, et une seconde config sur le même dossier est refusée.</a:t>
             </a:r>
           </a:p>
@@ -1443,6 +1741,32 @@
           <a:lstStyle/>
           <a:p>
             <a:r>
+              <a:t>🎤 Guillaume</a:t>
+            </a:r>
+          </a:p>
+          <a:p>
+            <a:r>
+              <a:t>• Pas de résolveur → pas de lockfile : le SHA épinglé EST le lock</a:t>
+            </a:r>
+          </a:p>
+          <a:p>
+            <a:r>
+              <a:t>• outdated → autoupdate → PR</a:t>
+            </a:r>
+          </a:p>
+          <a:p>
+            <a:r>
+              <a:t>↪ Mazlum : « Et l'autre question, sous mon post LinkedIn : pourquoi pas npx skills ? »</a:t>
+            </a:r>
+          </a:p>
+          <a:p/>
+          <a:p>
+            <a:r>
+              <a:t>────────</a:t>
+            </a:r>
+          </a:p>
+          <a:p>
+            <a:r>
               <a:t>On nous demande souvent : et le lockfile ? Un lockfile fige ce qu'un résolveur a choisi : des plages de versions et des dépendances transitives. pollen n'a ni l'un ni l'autre. Le commit épinglé dans pollen.yaml EST le lock, le tag en commentaire le rend lisible, et autoupdate --freeze (ou Renovate) le met à jour.</a:t>
             </a:r>
           </a:p>
@@ -1513,6 +1837,32 @@
           <a:lstStyle/>
           <a:p>
             <a:r>
+              <a:t>🎤 Mazlum, puis Guillaume, Mazlum conclut</a:t>
+            </a:r>
+          </a:p>
+          <a:p>
+            <a:r>
+              <a:t>• Mazlum : super outil, bien plus large, sait installer nos catalogues privés</a:t>
+            </a:r>
+          </a:p>
+          <a:p>
+            <a:r>
+              <a:t>• Guillaume : CLI + lock vs fichier déclaratif, sans package.json, épinglé sur une release</a:t>
+            </a:r>
+          </a:p>
+          <a:p>
+            <a:r>
+              <a:t>• Mazlum : les deux installent les mêmes skills, aucun lock-in</a:t>
+            </a:r>
+          </a:p>
+          <a:p/>
+          <a:p>
+            <a:r>
+              <a:t>────────</a:t>
+            </a:r>
+          </a:p>
+          <a:p>
+            <a:r>
               <a:t>La question qu'on nous pose le plus. npx skills (Vercel) installe aussi nos catalogues : repos privés en SSH, GitLab, chemins locaux, structure par domaines. La différence est dans le modèle. Eux : une CLI, des add successifs, un skills-lock.json qui retient le ref (souvent un tag) et un hash du contenu ; le déclaratif existe, en expérimental, dans le package.json. Nous : un pollen.yaml façon .pre-commit-config.yaml, à la racine de n'importe quel repo, Terraform, Python ou Java, sans package.json dans un repo qui n'a rien à voir avec npm. Chaque source est épinglée sur le commit d'une release, outdated part du dernier tag, et la montée de version se relit en PR. Eux sont bien plus larges ; nous, plus stricts pour une équipe. Les deux installent les mêmes skills : aucun lock-in.</a:t>
             </a:r>
           </a:p>
@@ -1583,6 +1933,32 @@
           <a:lstStyle/>
           <a:p>
             <a:r>
+              <a:t>🎤 Mazlum</a:t>
+            </a:r>
+          </a:p>
+          <a:p>
+            <a:r>
+              <a:t>• Ma vraie config : modules de l'orga (privés + publics), skill pollen, module perso</a:t>
+            </a:r>
+          </a:p>
+          <a:p>
+            <a:r>
+              <a:t>• Les règles de l'équipe et les miennes se composent sans se mélanger</a:t>
+            </a:r>
+          </a:p>
+          <a:p>
+            <a:r>
+              <a:t>↪ Guillaume : « Et on nous demande aussi : vous réinventez Spec Kit ? »</a:t>
+            </a:r>
+          </a:p>
+          <a:p/>
+          <a:p>
+            <a:r>
+              <a:t>────────</a:t>
+            </a:r>
+          </a:p>
+          <a:p>
+            <a:r>
               <a:t>Ma vraie config machine (les paths sont omis). Des modules de l'orga privés et publics, le skill de pollen lui-même, et un module perso sur mon compte : les règles d'équipe et les miennes se composent sans se mélanger. Un module perso vit sur le compte de celui qui le maintient ; un module d'équipe dans l'orga.</a:t>
             </a:r>
           </a:p>
@@ -1653,6 +2029,32 @@
           <a:lstStyle/>
           <a:p>
             <a:r>
+              <a:t>🎤 Guillaume</a:t>
+            </a:r>
+          </a:p>
+          <a:p>
+            <a:r>
+              <a:t>• Eux aussi en Agent Skills, mais ils encodent un processus (spec → plan → tâches)</a:t>
+            </a:r>
+          </a:p>
+          <a:p>
+            <a:r>
+              <a:t>• Nous, des conventions techniques : ils se composent</a:t>
+            </a:r>
+          </a:p>
+          <a:p>
+            <a:r>
+              <a:t>↪ Mazlum : « Assez parlé. Montrons-le. »</a:t>
+            </a:r>
+          </a:p>
+          <a:p/>
+          <a:p>
+            <a:r>
+              <a:t>────────</a:t>
+            </a:r>
+          </a:p>
+          <a:p>
+            <a:r>
               <a:t>Question qu'on nous pose souvent. Spec Kit (GitHub, v1.0) et BMAD (v6) sont eux-mêmes livrés en Agent Skills : /speckit-specify, plan, tasks… et les personas BMAD (analyste, PM, architecte, dev). Ils structurent le processus d'une feature. Nos conventions techniques, eux les prennent en prose : la constitution.md de Spec Kit, les persistent_facts de BMAD. Les deux se composent : un /speckit-plan dans un repo qui a nos skills sort un plan hexagonal, avec notre Dockerfile et notre CI. Et eux aussi ont leur CLI de distribution par projet : le problème qu'on résout avec pollen est le même pour tout le monde.</a:t>
             </a:r>
           </a:p>
@@ -1723,6 +2125,52 @@
           <a:lstStyle/>
           <a:p>
             <a:r>
+              <a:t>🎤 Démo, on alterne (script-demo.md) · le non-pilote décide de basculer sur les filets</a:t>
+            </a:r>
+          </a:p>
+          <a:p>
+            <a:r>
+              <a:t>0 · Cadrage : Mazlum parle</a:t>
+            </a:r>
+          </a:p>
+          <a:p>
+            <a:r>
+              <a:t>1 · SANS : Mazlum pilote, Guillaume commente (1 stage root, citation sans auteur)</a:t>
+            </a:r>
+          </a:p>
+          <a:p>
+            <a:r>
+              <a:t>2 · pollen update : Guillaume pilote, Mazlum commente (quote-domain)</a:t>
+            </a:r>
+          </a:p>
+          <a:p>
+            <a:r>
+              <a:t>3 · AVEC : Guillaume pilote, Mazlum commente (3 couches, non-root, ?lang=fr)</a:t>
+            </a:r>
+          </a:p>
+          <a:p>
+            <a:r>
+              <a:t>4 · Delta : ping-pong, une paire chacun → « Les règles sont là. »</a:t>
+            </a:r>
+          </a:p>
+          <a:p>
+            <a:r>
+              <a:t>5 · Déploiement : Guillaume pilote, Mazlum commente</a:t>
+            </a:r>
+          </a:p>
+          <a:p>
+            <a:r>
+              <a:t>↪ Guillaume : « Une bibliothèque de skills, ça se gouverne. »</a:t>
+            </a:r>
+          </a:p>
+          <a:p/>
+          <a:p>
+            <a:r>
+              <a:t>────────</a:t>
+            </a:r>
+          </a:p>
+          <a:p>
+            <a:r>
               <a:t>Session vierge = terminal gauche : claude --safe-mode --disable-slash-commands (ni CLAUDE.md, ni skills, même les built-in). Le moment clé, c'est le contraste. Ce ne sont pas les talents de l'IA qui font la différence, ce sont les règles. Filets : URL déjà déployée + screencast.</a:t>
             </a:r>
           </a:p>
@@ -1793,6 +2241,32 @@
           <a:lstStyle/>
           <a:p>
             <a:r>
+              <a:t>🎤 Mazlum</a:t>
+            </a:r>
+          </a:p>
+          <a:p>
+            <a:r>
+              <a:t>• Skills = code : versionnés, relus en PR, blast radius énorme</a:t>
+            </a:r>
+          </a:p>
+          <a:p>
+            <a:r>
+              <a:t>• Transverses : Guillaume et moi · Domaine : ceux qui le connaissent · « On est huit, pas Google »</a:t>
+            </a:r>
+          </a:p>
+          <a:p>
+            <a:r>
+              <a:t>↪ Guillaume : « Et même relu, un skill finit par vieillir. »</a:t>
+            </a:r>
+          </a:p>
+          <a:p/>
+          <a:p>
+            <a:r>
+              <a:t>────────</a:t>
+            </a:r>
+          </a:p>
+          <a:p>
+            <a:r>
               <a:t>Qui relit ? Les skills transverses (Docker, CI, IaC, commits…) : les référents tech, Guillaume et moi, qui les avons posés au départ. Un skill spécialisé, comme celui de l'API Solis, est porté par les référents du domaine : Iliass, chercheur, qui implémente une bonne partie des features de Solis, avec Youssef, lead API et produit, et Rafik, entre tech et produit. Des profils tech, spécialisés sur ce sujet, qui en savent plus que nous : on relit avec eux. Chez Orange, notre client, même modèle : les modules transverses sont tenus par les référents tech et l'équipe platform, les repos spécialisés par le référent de leur domaine. Toujours une PR, jamais relue par son seul auteur, et la CI vérifie le mécanique.</a:t>
             </a:r>
           </a:p>
@@ -1863,6 +2337,32 @@
           <a:lstStyle/>
           <a:p>
             <a:r>
+              <a:t>🎤 Guillaume, Mazlum, Guillaume</a:t>
+            </a:r>
+          </a:p>
+          <a:p>
+            <a:r>
+              <a:t>• Une règle périmée n'échoue pas : elle apprend le mauvais pattern (run-all → run --all)</a:t>
+            </a:r>
+          </a:p>
+          <a:p>
+            <a:r>
+              <a:t>• Mazlum : le factuel, un agent le repère ; « encore notre convention ? » reste humain</a:t>
+            </a:r>
+          </a:p>
+          <a:p>
+            <a:r>
+              <a:t>• Guillaume : une règle qui peut devenir un check en devient un</a:t>
+            </a:r>
+          </a:p>
+          <a:p/>
+          <a:p>
+            <a:r>
+              <a:t>────────</a:t>
+            </a:r>
+          </a:p>
+          <a:p>
+            <a:r>
               <a:t>Le vrai risque d'une lib de skills, c'est la règle périmée : elle ne casse rien, elle apprend en silence le mauvais pattern à l'agent. Ce qui pourrit, c'est le volatil : flags, versions, commandes. On l'isole du durable. War story : un skill Terragrunt référençait run-all, remplacé par run --all. Péremption factuelle, parfaite pour un scan IA. La péremption de jugement — est-ce encore notre convention ? — reste humaine, en revue. Quand une règle est mécanique, on en fait un check qui casse fort : le hook commit-msg qui refuse les co-auteurs IA, skill-validator sur chaque skill en CI. Ce qu'on n'a pas encore : des evals, un prompt de référence rejoué avec le skill pour prouver qu'il produit toujours le bon résultat. C'est notre démo avec et sans skills, automatisée. On va commencer par quelques skills mécaniques, Docker et commits.</a:t>
             </a:r>
           </a:p>
@@ -1933,6 +2433,32 @@
           <a:lstStyle/>
           <a:p>
             <a:r>
+              <a:t>🎤 Guillaume</a:t>
+            </a:r>
+          </a:p>
+          <a:p>
+            <a:r>
+              <a:t>• skill-validator : spec, liens, orphelins, taille</a:t>
+            </a:r>
+          </a:p>
+          <a:p>
+            <a:r>
+              <a:t>• Workflow partagé épinglé par SHA, Dependabot</a:t>
+            </a:r>
+          </a:p>
+          <a:p>
+            <a:r>
+              <a:t>↪ Mazlum : « Et on a appris une chose en route. »</a:t>
+            </a:r>
+          </a:p>
+          <a:p/>
+          <a:p>
+            <a:r>
+              <a:t>────────</a:t>
+            </a:r>
+          </a:p>
+          <a:p>
+            <a:r>
               <a:t>skill-validator (agent-ecosystem, open source) : conformité à la spec, budget de tokens, liens cassés, fichiers orphelins, qualité des descriptions. La CI vit dans un workflow partagé public, épinglé par commit ; Dependabot ouvre la PR quand il évolue.</a:t>
             </a:r>
           </a:p>
@@ -2003,6 +2529,32 @@
           <a:lstStyle/>
           <a:p>
             <a:r>
+              <a:t>🎤 Mazlum</a:t>
+            </a:r>
+          </a:p>
+          <a:p>
+            <a:r>
+              <a:t>• 1re montée de version de pollen : 13 fichiers à retoucher</a:t>
+            </a:r>
+          </a:p>
+          <a:p>
+            <a:r>
+              <a:t>• Désormais, la connaissance de pollen est un skill livré avec pollen</a:t>
+            </a:r>
+          </a:p>
+          <a:p>
+            <a:r>
+              <a:t>↪ Guillaume : « Et pour aller plus loin, on a regardé chez les gros. »</a:t>
+            </a:r>
+          </a:p>
+          <a:p/>
+          <a:p>
+            <a:r>
+              <a:t>────────</a:t>
+            </a:r>
+          </a:p>
+          <a:p>
+            <a:r>
               <a:t>War story : à la première montée de version de pollen, il a fallu retoucher 13 fichiers dans nos modules. C'était exactement le CLAUDE.md monolithique qu'on dénonce, dupliqué. La connaissance de l'outil est devenue un skill livré avec l'outil ; les modules n'ont plus rien à retoucher.</a:t>
             </a:r>
           </a:p>
@@ -2073,6 +2625,27 @@
           <a:lstStyle/>
           <a:p>
             <a:r>
+              <a:t>🎤 Les deux, 10 secondes</a:t>
+            </a:r>
+          </a:p>
+          <a:p>
+            <a:r>
+              <a:t>• Clin d'œil, on ne s'attarde pas : on lit le bandeau</a:t>
+            </a:r>
+          </a:p>
+          <a:p>
+            <a:r>
+              <a:t>↪ Mazlum enchaîne sur le contexte GroupBees</a:t>
+            </a:r>
+          </a:p>
+          <a:p/>
+          <a:p>
+            <a:r>
+              <a:t>────────</a:t>
+            </a:r>
+          </a:p>
+          <a:p>
+            <a:r>
               <a:t>Clin d'œil façon Guignols de l'info, on ne s'y attarde pas : « Comment GroupBees a standardisé ses conventions avec les Agent Skills ? C'est notre sujet. »</a:t>
             </a:r>
           </a:p>
@@ -2143,6 +2716,32 @@
           <a:lstStyle/>
           <a:p>
             <a:r>
+              <a:t>🎤 Mazlum</a:t>
+            </a:r>
+          </a:p>
+          <a:p>
+            <a:r>
+              <a:t>• « Skills are products, not snippets » ; evals obligatoires et hebdo, multi-agents</a:t>
+            </a:r>
+          </a:p>
+          <a:p>
+            <a:r>
+              <a:t>• Notre prochaine marche : les evals</a:t>
+            </a:r>
+          </a:p>
+          <a:p>
+            <a:r>
+              <a:t>• Adaptez la gouvernance à votre taille, mais gardez-en une</a:t>
+            </a:r>
+          </a:p>
+          <a:p/>
+          <a:p>
+            <a:r>
+              <a:t>────────</a:t>
+            </a:r>
+          </a:p>
+          <a:p>
+            <a:r>
               <a:t>Source : blog Google Cloud « Behind the scenes: how we build, test and scale Google agent skills » (août 2026). Leur CI : lint, vérification des liens, checklists assistées par IA, et surtout les evals. C'est là qu'on n'en est pas encore. Et un owner par skill : nous, on est huit, pas Google. Pas d'organigramme, mais ceux qui savent : les référents tech relisent le transverse, les référents d'un domaine portent ses skills spécialisés, et la CI vérifie le mécanique. Adaptez la gouvernance à votre taille, mais gardez-en une.</a:t>
             </a:r>
           </a:p>
@@ -2213,6 +2812,32 @@
           <a:lstStyle/>
           <a:p>
             <a:r>
+              <a:t>🎤 Un point chacun</a:t>
+            </a:r>
+          </a:p>
+          <a:p>
+            <a:r>
+              <a:t>• Mazlum : conventions dans des skills, pas un CLAUDE.md géant</a:t>
+            </a:r>
+          </a:p>
+          <a:p>
+            <a:r>
+              <a:t>• Guillaume : skills par projet, épinglés comme des dépendances</a:t>
+            </a:r>
+          </a:p>
+          <a:p>
+            <a:r>
+              <a:t>• Mazlum : gouvernés comme du code · Guillaume : « relecture, CI… et bientôt des evals »</a:t>
+            </a:r>
+          </a:p>
+          <a:p/>
+          <a:p>
+            <a:r>
+              <a:t>────────</a:t>
+            </a:r>
+          </a:p>
+          <a:p>
+            <a:r>
               <a:t>Trois idées à ramener lundi matin dans votre équipe.</a:t>
             </a:r>
           </a:p>
@@ -2283,6 +2908,32 @@
           <a:lstStyle/>
           <a:p>
             <a:r>
+              <a:t>🎤 Les deux</a:t>
+            </a:r>
+          </a:p>
+          <a:p>
+            <a:r>
+              <a:t>• Mazlum : « Ce n'est pas par magie que l'IA a codé comme nous. »</a:t>
+            </a:r>
+          </a:p>
+          <a:p>
+            <a:r>
+              <a:t>• Guillaume : « C'est parce que les règles sont là. »</a:t>
+            </a:r>
+          </a:p>
+          <a:p>
+            <a:r>
+              <a:t>• Mazlum : « Merci ! On prend vos questions. »</a:t>
+            </a:r>
+          </a:p>
+          <a:p/>
+          <a:p>
+            <a:r>
+              <a:t>────────</a:t>
+            </a:r>
+          </a:p>
+          <a:p>
+            <a:r>
               <a:t>Merci ! On prend vos questions.</a:t>
             </a:r>
           </a:p>
@@ -2353,6 +3004,32 @@
           <a:lstStyle/>
           <a:p>
             <a:r>
+              <a:t>🎤 Mazlum</a:t>
+            </a:r>
+          </a:p>
+          <a:p>
+            <a:r>
+              <a:t>• Registre d'API : producteurs publient, consommateurs découvrent, IA par-dessus</a:t>
+            </a:r>
+          </a:p>
+          <a:p>
+            <a:r>
+              <a:t>• Stack exigeante : hexagonal, Terragrunt, Workload Identity, IAP</a:t>
+            </a:r>
+          </a:p>
+          <a:p>
+            <a:r>
+              <a:t>↪ « Et derrière, une équipe qui n'a pas le même niveau sur tout ça. Guillaume ? »</a:t>
+            </a:r>
+          </a:p>
+          <a:p/>
+          <a:p>
+            <a:r>
+              <a:t>────────</a:t>
+            </a:r>
+          </a:p>
+          <a:p>
+            <a:r>
               <a:t>TODO : préciser en une phrase ce que l'IA génère sur la plateforme. L'idée : poser une stack moderne mais exigeante — hexagonal, Terragrunt, WIF, IAP. Pas triviale pour tout le monde.</a:t>
             </a:r>
           </a:p>
@@ -2423,6 +3100,32 @@
           <a:lstStyle/>
           <a:p>
             <a:r>
+              <a:t>🎤 Guillaume</a:t>
+            </a:r>
+          </a:p>
+          <a:p>
+            <a:r>
+              <a:t>• 8 personnes : quelques seniors, un junior, un stagiaire</a:t>
+            </a:r>
+          </a:p>
+          <a:p>
+            <a:r>
+              <a:t>• Grâce à Claude, tout le monde fait évoluer les stacks : la bonne nouvelle</a:t>
+            </a:r>
+          </a:p>
+          <a:p>
+            <a:r>
+              <a:t>↪ Mazlum : « La mauvaise, c'est la suite. »</a:t>
+            </a:r>
+          </a:p>
+          <a:p/>
+          <a:p>
+            <a:r>
+              <a:t>────────</a:t>
+            </a:r>
+          </a:p>
+          <a:p>
+            <a:r>
               <a:t>Les seniors ont généré le premier backend, les fondations cloud et l'IaC — et, plus tard, les premiers skills transverses. Avec leur Claude, les autres ont réussi à faire évoluer ces stacks — c'est le côté positif.</a:t>
             </a:r>
           </a:p>
@@ -2493,6 +3196,32 @@
           <a:lstStyle/>
           <a:p>
             <a:r>
+              <a:t>🎤 Mazlum</a:t>
+            </a:r>
+          </a:p>
+          <a:p>
+            <a:r>
+              <a:t>• Nouveau service, nouvelle stack IaC → nos conventions disparaissent</a:t>
+            </a:r>
+          </a:p>
+          <a:p>
+            <a:r>
+              <a:t>• Chacun son Claude, son CLAUDE.md : l'IA ne connaît pas NOS règles</a:t>
+            </a:r>
+          </a:p>
+          <a:p>
+            <a:r>
+              <a:t>↪ Guillaume : « Donc on a fait ce que tout le monde fait. »</a:t>
+            </a:r>
+          </a:p>
+          <a:p/>
+          <a:p>
+            <a:r>
+              <a:t>────────</a:t>
+            </a:r>
+          </a:p>
+          <a:p>
+            <a:r>
               <a:t>Dès qu'il fallait générer quelque chose de nouveau — un nouveau service back, une nouvelle stack IaC — les conventions n'étaient pas respectées. L'IA est douée, mais elle ne connaît pas NOS règles.</a:t>
             </a:r>
           </a:p>
@@ -2563,6 +3292,27 @@
           <a:lstStyle/>
           <a:p>
             <a:r>
+              <a:t>🎤 Guillaume</a:t>
+            </a:r>
+          </a:p>
+          <a:p>
+            <a:r>
+              <a:t>• Un CLAUDE.md partagé, toutes les règles au même endroit</a:t>
+            </a:r>
+          </a:p>
+          <a:p>
+            <a:r>
+              <a:t>↪ Mazlum : « Simple… pendant deux semaines. »</a:t>
+            </a:r>
+          </a:p>
+          <a:p/>
+          <a:p>
+            <a:r>
+              <a:t>────────</a:t>
+            </a:r>
+          </a:p>
+          <a:p>
+            <a:r>
               <a:t>Premier réflexe, naturel : on écrit un CLAUDE.md qu'on se partage. Toutes nos règles au même endroit.</a:t>
             </a:r>
           </a:p>
@@ -2633,6 +3383,32 @@
           <a:lstStyle/>
           <a:p>
             <a:r>
+              <a:t>🎤 Guillaume (montrer le vrai fichier qui scrolle)</a:t>
+            </a:r>
+          </a:p>
+          <a:p>
+            <a:r>
+              <a:t>• Chargé tout le temps : un commit relit les règles Dockerfile</a:t>
+            </a:r>
+          </a:p>
+          <a:p>
+            <a:r>
+              <a:t>• Coûte des tokens, dilue l'attention</a:t>
+            </a:r>
+          </a:p>
+          <a:p>
+            <a:r>
+              <a:t>↪ Mazlum : « Alors on l'a découpé. »</a:t>
+            </a:r>
+          </a:p>
+          <a:p/>
+          <a:p>
+            <a:r>
+              <a:t>────────</a:t>
+            </a:r>
+          </a:p>
+          <a:p>
+            <a:r>
               <a:t>Montrer un vrai CLAUDE.md qui scrolle sans fin. Le problème n'est pas le contenu, c'est qu'il est chargé en permanence, même quand on écrit un commit et pas un Dockerfile.</a:t>
             </a:r>
           </a:p>
@@ -2701,6 +3477,27 @@
         <p:txBody>
           <a:bodyPr/>
           <a:lstStyle/>
+          <a:p>
+            <a:r>
+              <a:t>🎤 Mazlum</a:t>
+            </a:r>
+          </a:p>
+          <a:p>
+            <a:r>
+              <a:t>• Un skill = un CLAUDE.md modulaire, chargé à la demande</a:t>
+            </a:r>
+          </a:p>
+          <a:p>
+            <a:r>
+              <a:t>• Une convention, un skill</a:t>
+            </a:r>
+          </a:p>
+          <a:p/>
+          <a:p>
+            <a:r>
+              <a:t>────────</a:t>
+            </a:r>
+          </a:p>
           <a:p>
             <a:r>
               <a:t>Naturellement, on a découpé : c'est l'idée des skills. Un CLAUDE.md modulaire, chargé à la demande.</a:t>

</xml_diff>

<commit_message>
Slide npx skills : Guillaume raconte qu'il l'avait regardé avant pollen
</commit_message>
<xml_diff>
--- a/talks/slides/talk_devfest_skills.pptx
+++ b/talks/slides/talk_devfest_skills.pptx
@@ -1843,6 +1843,11 @@
           <a:p>
             <a:r>
               <a:t>• Mazlum : super outil, bien plus large, sait installer nos catalogues privés</a:t>
+            </a:r>
+          </a:p>
+          <a:p>
+            <a:r>
+              <a:t>• Guillaume : avant pollen, seul outil open source trouvé, on l'a regardé</a:t>
             </a:r>
           </a:p>
           <a:p>

</xml_diff>

<commit_message>
Démo sans déploiement : lancements enchaînés, delta mesuré, release vitrine
- script-demo.md : 7 beats (~10 min), SANS génère pendant pollen update,
  AVEC pendant le commentaire de SANS, fin sur une vraie release dans le
  navigateur ; artefacts mesurés, reset depuis origin/main
- dialogue.md et repère de scène de la slide démo alignés ; plus de
  « en root » ni « sans auteur », que SANS fait déjà
- demo-prep.md : filets URL et déploiement GHA remplacés par les sorties
  pré-capturées
</commit_message>
<xml_diff>
--- a/talks/slides/talk_devfest_skills.pptx
+++ b/talks/slides/talk_devfest_skills.pptx
@@ -2140,27 +2140,32 @@
           </a:p>
           <a:p>
             <a:r>
-              <a:t>1 · SANS : Mazlum pilote, Guillaume commente (1 stage root, citation sans auteur)</a:t>
-            </a:r>
-          </a:p>
-          <a:p>
-            <a:r>
-              <a:t>2 · pollen update : Guillaume pilote, Mazlum commente (quote-domain)</a:t>
-            </a:r>
-          </a:p>
-          <a:p>
-            <a:r>
-              <a:t>3 · AVEC : Guillaume pilote, Mazlum commente (3 couches, non-root, ?lang=fr)</a:t>
-            </a:r>
-          </a:p>
-          <a:p>
-            <a:r>
-              <a:t>4 · Delta : ping-pong, une paire chacun → « Les règles sont là. »</a:t>
-            </a:r>
-          </a:p>
-          <a:p>
-            <a:r>
-              <a:t>5 · Déploiement : Guillaume pilote, Mazlum commente</a:t>
+              <a:t>1 · Lancer SANS : Mazlum pilote, Guillaume commente</a:t>
+            </a:r>
+          </a:p>
+          <a:p>
+            <a:r>
+              <a:t>2 · pollen update + lancer AVEC : Guillaume pilote, Mazlum commente (quote-domain)</a:t>
+            </a:r>
+          </a:p>
+          <a:p>
+            <a:r>
+              <a:t>3 · Sortie SANS : pip, 1 stage, GetRandomQuote, README seul (PAS « root » ni « sans auteur »)</a:t>
+            </a:r>
+          </a:p>
+          <a:p>
+            <a:r>
+              <a:t>4 · Sortie AVEC : 3 couches, UseCase, uv multi-stage, AGENTS.md, ?lang=fr</a:t>
+            </a:r>
+          </a:p>
+          <a:p>
+            <a:r>
+              <a:t>5 · Delta : ping-pong → « Les règles sont là. »</a:t>
+            </a:r>
+          </a:p>
+          <a:p>
+            <a:r>
+              <a:t>6 · Release dans le navigateur : Mazlum pilote, Guillaume commente</a:t>
             </a:r>
           </a:p>
           <a:p>
@@ -2176,7 +2181,7 @@
           </a:p>
           <a:p>
             <a:r>
-              <a:t>Session vierge = terminal gauche : claude --safe-mode --disable-slash-commands (ni CLAUDE.md, ni skills, même les built-in). Le moment clé, c'est le contraste. Ce ne sont pas les talents de l'IA qui font la différence, ce sont les règles. Filets : URL déjà déployée + screencast.</a:t>
+              <a:t>Session vierge = terminal gauche : claude --safe-mode --disable-slash-commands (ni CLAUDE.md, ni skills, même les built-in). Le moment clé, c'est le contraste. Ce ne sont pas les talents de l'IA qui font la différence, ce sont les règles. Pas de déploiement en live : une vraie release déjà publiée, dans le navigateur. Filets : sorties pré-capturées + screencast.</a:t>
             </a:r>
           </a:p>
         </p:txBody>
@@ -22123,7 +22128,7 @@
                 </a:solidFill>
                 <a:latin typeface="Avenir Next"/>
               </a:rPr>
-              <a:t>Même prompt : hexagonal, Dockerfile, tests, CI</a:t>
+              <a:t>Même prompt : uv, hexagonal, Dockerfile, tests, CI, AGENTS.md</a:t>
             </a:r>
           </a:p>
         </p:txBody>
@@ -22206,7 +22211,7 @@
                 </a:solidFill>
                 <a:latin typeface="Avenir Next"/>
               </a:rPr>
-              <a:t>Commit squashé, PR labellisée, pipeline jusqu'à Cloud Run</a:t>
+              <a:t>Le delta, puis une vraie release : tag, PR labellisées, notes</a:t>
             </a:r>
           </a:p>
         </p:txBody>

</xml_diff>

<commit_message>
Slide « Essayez-le » et QR de fin : feedback, LinkedIn des speakers
- Nouvelle slide 32 (type links) : QR pollen et QR skills-gitlab,
  catalogue public rangé par domaines, commande d'installation
- Slide de fin : FEEDBACK_QR en grand (None tant que DevFest n'a pas
  fourni le sien), LinkedIn de Mazlum et Guillaume en petit
- build_cloud_nord.sh remplace FEEDBACK_QR par OpenFeedback
- Dialogue et déroulé passés à 33 slides, antisèche régénérée
</commit_message>
<xml_diff>
--- a/talks/slides/talk_devfest_skills.pptx
+++ b/talks/slides/talk_devfest_skills.pptx
@@ -37,6 +37,7 @@
     <p:sldId id="285" r:id="rId37"/>
     <p:sldId id="286" r:id="rId38"/>
     <p:sldId id="287" r:id="rId39"/>
+    <p:sldId id="288" r:id="rId40"/>
   </p:sldIdLst>
   <p:sldSz cx="12191695" cy="6858000" type="screen4x3"/>
   <p:notesSz cx="6858000" cy="9144000"/>
@@ -2874,6 +2875,102 @@
 </file>
 
 <file path=ppt/notesSlides/notesSlide32.xml><?xml version="1.0" encoding="utf-8"?>
+<p:notes xmlns:a="http://schemas.openxmlformats.org/drawingml/2006/main" xmlns:p="http://schemas.openxmlformats.org/presentationml/2006/main" xmlns:r="http://schemas.openxmlformats.org/officeDocument/2006/relationships">
+  <p:cSld>
+    <p:spTree>
+      <p:nvGrpSpPr>
+        <p:cNvPr id="1" name=""/>
+        <p:cNvGrpSpPr/>
+        <p:nvPr/>
+      </p:nvGrpSpPr>
+      <p:grpSpPr>
+        <a:xfrm>
+          <a:off x="0" y="0"/>
+          <a:ext cx="0" cy="0"/>
+          <a:chOff x="0" y="0"/>
+          <a:chExt cx="0" cy="0"/>
+        </a:xfrm>
+      </p:grpSpPr>
+      <p:sp>
+        <p:nvSpPr>
+          <p:cNvPr id="2" name="Slide Image Placeholder 1"/>
+          <p:cNvSpPr>
+            <a:spLocks noGrp="1"/>
+          </p:cNvSpPr>
+          <p:nvPr>
+            <p:ph type="sldImg" idx="2"/>
+          </p:nvPr>
+        </p:nvSpPr>
+        <p:spPr/>
+      </p:sp>
+      <p:sp>
+        <p:nvSpPr>
+          <p:cNvPr id="3" name="Notes Placeholder 2"/>
+          <p:cNvSpPr>
+            <a:spLocks noGrp="1"/>
+          </p:cNvSpPr>
+          <p:nvPr>
+            <p:ph type="body" idx="3" sz="quarter"/>
+          </p:nvPr>
+        </p:nvSpPr>
+        <p:spPr/>
+        <p:txBody>
+          <a:bodyPr/>
+          <a:lstStyle/>
+          <a:p>
+            <a:r>
+              <a:t>🎤 Mazlum ou Guillaume (à répartir)</a:t>
+            </a:r>
+          </a:p>
+          <a:p>
+            <a:r>
+              <a:t>• « De quoi l'essayer ce soir : pollen, et un catalogue public rangé par domaines »</a:t>
+            </a:r>
+          </a:p>
+          <a:p>
+            <a:r>
+              <a:t>• Le pollen.yaml du README marche tel quel · laisser 10 s pour scanner</a:t>
+            </a:r>
+          </a:p>
+          <a:p>
+            <a:r>
+              <a:t>• Aux questions, revenir ici si on demande un lien</a:t>
+            </a:r>
+          </a:p>
+          <a:p/>
+          <a:p>
+            <a:r>
+              <a:t>────────</a:t>
+            </a:r>
+          </a:p>
+          <a:p>
+            <a:r>
+              <a:t>De quoi l'essayer ce soir. pollen, et un catalogue public rangé par domaines, comme celui de la démo : le pollen.yaml du README marche tel quel.</a:t>
+            </a:r>
+          </a:p>
+        </p:txBody>
+      </p:sp>
+      <p:sp>
+        <p:nvSpPr>
+          <p:cNvPr id="4" name="Slide Number Placeholder 3"/>
+          <p:cNvSpPr>
+            <a:spLocks noGrp="1"/>
+          </p:cNvSpPr>
+          <p:nvPr>
+            <p:ph type="sldNum" idx="5" sz="quarter"/>
+          </p:nvPr>
+        </p:nvSpPr>
+        <p:spPr/>
+      </p:sp>
+    </p:spTree>
+  </p:cSld>
+  <p:clrMapOvr>
+    <a:masterClrMapping/>
+  </p:clrMapOvr>
+</p:notes>
+</file>
+
+<file path=ppt/notesSlides/notesSlide33.xml><?xml version="1.0" encoding="utf-8"?>
 <p:notes xmlns:a="http://schemas.openxmlformats.org/drawingml/2006/main" xmlns:p="http://schemas.openxmlformats.org/presentationml/2006/main" xmlns:r="http://schemas.openxmlformats.org/officeDocument/2006/relationships">
   <p:cSld>
     <p:spTree>
@@ -7585,7 +7682,7 @@
                 </a:solidFill>
                 <a:latin typeface="Avenir Next"/>
               </a:rPr>
-              <a:t>Industrialiser l'IA en équipe · DevFest Toulouse   ·   9/31</a:t>
+              <a:t>Industrialiser l'IA en équipe · DevFest Toulouse   ·   9/32</a:t>
             </a:r>
           </a:p>
         </p:txBody>
@@ -8149,7 +8246,7 @@
                 </a:solidFill>
                 <a:latin typeface="Avenir Next"/>
               </a:rPr>
-              <a:t>Industrialiser l'IA en équipe · DevFest Toulouse   ·   10/31</a:t>
+              <a:t>Industrialiser l'IA en équipe · DevFest Toulouse   ·   10/32</a:t>
             </a:r>
           </a:p>
         </p:txBody>
@@ -9430,7 +9527,7 @@
                 </a:solidFill>
                 <a:latin typeface="Avenir Next"/>
               </a:rPr>
-              <a:t>Industrialiser l'IA en équipe · DevFest Toulouse   ·   11/31</a:t>
+              <a:t>Industrialiser l'IA en équipe · DevFest Toulouse   ·   11/32</a:t>
             </a:r>
           </a:p>
         </p:txBody>
@@ -9938,7 +10035,7 @@
                 </a:solidFill>
                 <a:latin typeface="Avenir Next"/>
               </a:rPr>
-              <a:t>Industrialiser l'IA en équipe · DevFest Toulouse   ·   12/31</a:t>
+              <a:t>Industrialiser l'IA en équipe · DevFest Toulouse   ·   12/32</a:t>
             </a:r>
           </a:p>
         </p:txBody>
@@ -10903,7 +11000,7 @@
                 </a:solidFill>
                 <a:latin typeface="Avenir Next"/>
               </a:rPr>
-              <a:t>Industrialiser l'IA en équipe · DevFest Toulouse   ·   13/31</a:t>
+              <a:t>Industrialiser l'IA en équipe · DevFest Toulouse   ·   13/32</a:t>
             </a:r>
           </a:p>
         </p:txBody>
@@ -11527,7 +11624,7 @@
                 </a:solidFill>
                 <a:latin typeface="Avenir Next"/>
               </a:rPr>
-              <a:t>Industrialiser l'IA en équipe · DevFest Toulouse   ·   14/31</a:t>
+              <a:t>Industrialiser l'IA en équipe · DevFest Toulouse   ·   14/32</a:t>
             </a:r>
           </a:p>
         </p:txBody>
@@ -12700,7 +12797,7 @@
                 </a:solidFill>
                 <a:latin typeface="Avenir Next"/>
               </a:rPr>
-              <a:t>Industrialiser l'IA en équipe · DevFest Toulouse   ·   15/31</a:t>
+              <a:t>Industrialiser l'IA en équipe · DevFest Toulouse   ·   15/32</a:t>
             </a:r>
           </a:p>
         </p:txBody>
@@ -13795,7 +13892,7 @@
                 </a:solidFill>
                 <a:latin typeface="Avenir Next"/>
               </a:rPr>
-              <a:t>Industrialiser l'IA en équipe · DevFest Toulouse   ·   16/31</a:t>
+              <a:t>Industrialiser l'IA en équipe · DevFest Toulouse   ·   16/32</a:t>
             </a:r>
           </a:p>
         </p:txBody>
@@ -14905,7 +15002,7 @@
                 </a:solidFill>
                 <a:latin typeface="Avenir Next"/>
               </a:rPr>
-              <a:t>Industrialiser l'IA en équipe · DevFest Toulouse   ·   17/31</a:t>
+              <a:t>Industrialiser l'IA en équipe · DevFest Toulouse   ·   17/32</a:t>
             </a:r>
           </a:p>
         </p:txBody>
@@ -15545,7 +15642,7 @@
                 </a:solidFill>
                 <a:latin typeface="Avenir Next"/>
               </a:rPr>
-              <a:t>Industrialiser l'IA en équipe · DevFest Toulouse   ·   18/31</a:t>
+              <a:t>Industrialiser l'IA en équipe · DevFest Toulouse   ·   18/32</a:t>
             </a:r>
           </a:p>
         </p:txBody>
@@ -16805,7 +16902,7 @@
                 </a:solidFill>
                 <a:latin typeface="Avenir Next"/>
               </a:rPr>
-              <a:t>Industrialiser l'IA en équipe · DevFest Toulouse   ·   1/31</a:t>
+              <a:t>Industrialiser l'IA en équipe · DevFest Toulouse   ·   1/32</a:t>
             </a:r>
           </a:p>
         </p:txBody>
@@ -17905,7 +18002,7 @@
                 </a:solidFill>
                 <a:latin typeface="Avenir Next"/>
               </a:rPr>
-              <a:t>Industrialiser l'IA en équipe · DevFest Toulouse   ·   19/31</a:t>
+              <a:t>Industrialiser l'IA en équipe · DevFest Toulouse   ·   19/32</a:t>
             </a:r>
           </a:p>
         </p:txBody>
@@ -18481,7 +18578,7 @@
                 </a:solidFill>
                 <a:latin typeface="Avenir Next"/>
               </a:rPr>
-              <a:t>Industrialiser l'IA en équipe · DevFest Toulouse   ·   20/31</a:t>
+              <a:t>Industrialiser l'IA en équipe · DevFest Toulouse   ·   20/32</a:t>
             </a:r>
           </a:p>
         </p:txBody>
@@ -19630,7 +19727,7 @@
                 </a:solidFill>
                 <a:latin typeface="Avenir Next"/>
               </a:rPr>
-              <a:t>Industrialiser l'IA en équipe · DevFest Toulouse   ·   21/31</a:t>
+              <a:t>Industrialiser l'IA en équipe · DevFest Toulouse   ·   21/32</a:t>
             </a:r>
           </a:p>
         </p:txBody>
@@ -20162,7 +20259,7 @@
                 </a:solidFill>
                 <a:latin typeface="Avenir Next"/>
               </a:rPr>
-              <a:t>Industrialiser l'IA en équipe · DevFest Toulouse   ·   22/31</a:t>
+              <a:t>Industrialiser l'IA en équipe · DevFest Toulouse   ·   22/32</a:t>
             </a:r>
           </a:p>
         </p:txBody>
@@ -21467,7 +21564,7 @@
                 </a:solidFill>
                 <a:latin typeface="Avenir Next"/>
               </a:rPr>
-              <a:t>Industrialiser l'IA en équipe · DevFest Toulouse   ·   23/31</a:t>
+              <a:t>Industrialiser l'IA en équipe · DevFest Toulouse   ·   23/32</a:t>
             </a:r>
           </a:p>
         </p:txBody>
@@ -22274,7 +22371,7 @@
                 </a:solidFill>
                 <a:latin typeface="Avenir Next"/>
               </a:rPr>
-              <a:t>Industrialiser l'IA en équipe · DevFest Toulouse   ·   24/31</a:t>
+              <a:t>Industrialiser l'IA en équipe · DevFest Toulouse   ·   24/32</a:t>
             </a:r>
           </a:p>
         </p:txBody>
@@ -23384,7 +23481,7 @@
                 </a:solidFill>
                 <a:latin typeface="Avenir Next"/>
               </a:rPr>
-              <a:t>Industrialiser l'IA en équipe · DevFest Toulouse   ·   25/31</a:t>
+              <a:t>Industrialiser l'IA en équipe · DevFest Toulouse   ·   25/32</a:t>
             </a:r>
           </a:p>
         </p:txBody>
@@ -24494,7 +24591,7 @@
                 </a:solidFill>
                 <a:latin typeface="Avenir Next"/>
               </a:rPr>
-              <a:t>Industrialiser l'IA en équipe · DevFest Toulouse   ·   26/31</a:t>
+              <a:t>Industrialiser l'IA en équipe · DevFest Toulouse   ·   26/32</a:t>
             </a:r>
           </a:p>
         </p:txBody>
@@ -25086,7 +25183,7 @@
                 </a:solidFill>
                 <a:latin typeface="Avenir Next"/>
               </a:rPr>
-              <a:t>Industrialiser l'IA en équipe · DevFest Toulouse   ·   27/31</a:t>
+              <a:t>Industrialiser l'IA en équipe · DevFest Toulouse   ·   27/32</a:t>
             </a:r>
           </a:p>
         </p:txBody>
@@ -26064,7 +26161,7 @@
                 </a:solidFill>
                 <a:latin typeface="Avenir Next"/>
               </a:rPr>
-              <a:t>Industrialiser l'IA en équipe · DevFest Toulouse   ·   28/31</a:t>
+              <a:t>Industrialiser l'IA en équipe · DevFest Toulouse   ·   28/32</a:t>
             </a:r>
           </a:p>
         </p:txBody>
@@ -26404,7 +26501,7 @@
                 </a:solidFill>
                 <a:latin typeface="Avenir Next"/>
               </a:rPr>
-              <a:t>Industrialiser l'IA en équipe · DevFest Toulouse   ·   2/31</a:t>
+              <a:t>Industrialiser l'IA en équipe · DevFest Toulouse   ·   2/32</a:t>
             </a:r>
           </a:p>
         </p:txBody>
@@ -27382,7 +27479,7 @@
                 </a:solidFill>
                 <a:latin typeface="Avenir Next"/>
               </a:rPr>
-              <a:t>Industrialiser l'IA en équipe · DevFest Toulouse   ·   29/31</a:t>
+              <a:t>Industrialiser l'IA en équipe · DevFest Toulouse   ·   29/32</a:t>
             </a:r>
           </a:p>
         </p:txBody>
@@ -28367,7 +28464,7 @@
                 </a:solidFill>
                 <a:latin typeface="Avenir Next"/>
               </a:rPr>
-              <a:t>Industrialiser l'IA en équipe · DevFest Toulouse   ·   30/31</a:t>
+              <a:t>Industrialiser l'IA en équipe · DevFest Toulouse   ·   30/32</a:t>
             </a:r>
           </a:p>
         </p:txBody>
@@ -28498,40 +28595,16 @@
           </a:p>
         </p:txBody>
       </p:sp>
-      <p:pic>
-        <p:nvPicPr>
-          <p:cNvPr id="4" name="bee_happy.png" descr="bee_happy.png"/>
-          <p:cNvPicPr>
-            <a:picLocks noChangeAspect="1"/>
-          </p:cNvPicPr>
-          <p:nvPr/>
-        </p:nvPicPr>
-        <p:blipFill>
-          <a:blip r:embed="rId2"/>
-          <a:stretch>
-            <a:fillRect/>
-          </a:stretch>
-        </p:blipFill>
-        <p:spPr>
-          <a:xfrm>
-            <a:off x="8778240" y="1645920"/>
-            <a:ext cx="3081258" cy="3840480"/>
-          </a:xfrm>
-          <a:prstGeom prst="rect">
-            <a:avLst/>
-          </a:prstGeom>
-        </p:spPr>
-      </p:pic>
-      <p:sp>
-        <p:nvSpPr>
-          <p:cNvPr id="5" name="TextBox 4"/>
+      <p:sp>
+        <p:nvSpPr>
+          <p:cNvPr id="4" name="TextBox 3"/>
           <p:cNvSpPr txBox="1"/>
           <p:nvPr/>
         </p:nvSpPr>
         <p:spPr>
           <a:xfrm>
-            <a:off x="640080" y="2194560"/>
-            <a:ext cx="7863840" cy="1280160"/>
+            <a:off x="640080" y="457200"/>
+            <a:ext cx="10881360" cy="914400"/>
           </a:xfrm>
           <a:prstGeom prst="rect">
             <a:avLst/>
@@ -28550,27 +28623,27 @@
               </a:spcAft>
             </a:pPr>
             <a:r>
-              <a:rPr sz="5400" b="1">
+              <a:rPr sz="3400" b="1">
                 <a:solidFill>
                   <a:srgbClr val="FFFFFF"/>
                 </a:solidFill>
                 <a:latin typeface="Avenir Next"/>
               </a:rPr>
-              <a:t>Pas par magie.</a:t>
-            </a:r>
-          </a:p>
-        </p:txBody>
-      </p:sp>
-      <p:sp>
-        <p:nvSpPr>
-          <p:cNvPr id="6" name="Rectangle 5"/>
+              <a:t>Essayez-le</a:t>
+            </a:r>
+          </a:p>
+        </p:txBody>
+      </p:sp>
+      <p:sp>
+        <p:nvSpPr>
+          <p:cNvPr id="5" name="Rectangle 4"/>
           <p:cNvSpPr/>
           <p:nvPr/>
         </p:nvSpPr>
         <p:spPr>
           <a:xfrm>
-            <a:off x="640080" y="3566160"/>
-            <a:ext cx="2194560" cy="91440"/>
+            <a:off x="640080" y="1207008"/>
+            <a:ext cx="1371600" cy="73152"/>
           </a:xfrm>
           <a:prstGeom prst="rect">
             <a:avLst/>
@@ -28615,91 +28688,309 @@
       </p:sp>
       <p:sp>
         <p:nvSpPr>
-          <p:cNvPr id="7" name="TextBox 6"/>
-          <p:cNvSpPr txBox="1"/>
-          <p:nvPr/>
-        </p:nvSpPr>
-        <p:spPr>
-          <a:xfrm>
-            <a:off x="640080" y="3931920"/>
-            <a:ext cx="7498079" cy="1828800"/>
-          </a:xfrm>
-          <a:prstGeom prst="rect">
-            <a:avLst/>
-          </a:prstGeom>
-          <a:noFill/>
-        </p:spPr>
-        <p:txBody>
-          <a:bodyPr wrap="square" lIns="0" rIns="0" tIns="0" bIns="0">
-            <a:spAutoFit/>
-          </a:bodyPr>
-          <a:lstStyle/>
-          <a:p>
-            <a:pPr algn="l">
-              <a:spcAft>
-                <a:spcPts val="1000"/>
-              </a:spcAft>
-            </a:pPr>
-            <a:r>
-              <a:rPr sz="2000">
-                <a:solidFill>
-                  <a:srgbClr val="C9CFDC"/>
-                </a:solidFill>
-                <a:latin typeface="Avenir Next"/>
-              </a:rPr>
-              <a:t>Parce que les règles sont là.</a:t>
-            </a:r>
-          </a:p>
-          <a:p>
-            <a:pPr algn="l">
-              <a:spcAft>
-                <a:spcPts val="1000"/>
-              </a:spcAft>
-            </a:pPr>
-            <a:r>
-              <a:rPr sz="2000">
-                <a:solidFill>
-                  <a:srgbClr val="C9CFDC"/>
-                </a:solidFill>
-                <a:latin typeface="Avenir Next"/>
-              </a:rPr>
-              <a:t>github.com/groupbees/pollen</a:t>
-            </a:r>
-          </a:p>
-          <a:p>
-            <a:pPr algn="l">
-              <a:spcAft>
-                <a:spcPts val="1000"/>
-              </a:spcAft>
-            </a:pPr>
-            <a:r>
-              <a:rPr sz="2000">
-                <a:solidFill>
-                  <a:srgbClr val="C9CFDC"/>
-                </a:solidFill>
-                <a:latin typeface="Avenir Next"/>
-              </a:rPr>
-              <a:t>Merci ! Des questions ?</a:t>
-            </a:r>
+          <p:cNvPr id="6" name="Rounded Rectangle 5"/>
+          <p:cNvSpPr/>
+          <p:nvPr/>
+        </p:nvSpPr>
+        <p:spPr>
+          <a:xfrm>
+            <a:off x="2602839" y="1581912"/>
+            <a:ext cx="2596896" cy="2596896"/>
+          </a:xfrm>
+          <a:prstGeom prst="roundRect">
+            <a:avLst>
+              <a:gd name="adj" fmla="val 5000"/>
+            </a:avLst>
+          </a:prstGeom>
+          <a:solidFill>
+            <a:srgbClr val="FFFFFF"/>
+          </a:solidFill>
+          <a:ln>
+            <a:noFill/>
+          </a:ln>
+          <a:effectLst/>
+        </p:spPr>
+        <p:style>
+          <a:lnRef idx="1">
+            <a:schemeClr val="accent1"/>
+          </a:lnRef>
+          <a:fillRef idx="3">
+            <a:schemeClr val="accent1"/>
+          </a:fillRef>
+          <a:effectRef idx="2">
+            <a:schemeClr val="accent1"/>
+          </a:effectRef>
+          <a:fontRef idx="minor">
+            <a:schemeClr val="lt1"/>
+          </a:fontRef>
+        </p:style>
+        <p:txBody>
+          <a:bodyPr rtlCol="0" anchor="ctr"/>
+          <a:lstStyle/>
+          <a:p>
+            <a:pPr algn="ctr"/>
           </a:p>
         </p:txBody>
       </p:sp>
       <p:pic>
         <p:nvPicPr>
-          <p:cNvPr id="8" name="logo_light.png" descr="logo_light.png"/>
+          <p:cNvPr id="7" name="qr_pollen.png" descr="qr_pollen.png"/>
           <p:cNvPicPr>
             <a:picLocks noChangeAspect="1"/>
           </p:cNvPicPr>
           <p:nvPr/>
         </p:nvPicPr>
         <p:blipFill>
-          <a:blip r:embed="rId4"/>
+          <a:blip r:embed="rId2"/>
           <a:stretch>
             <a:fillRect/>
           </a:stretch>
         </p:blipFill>
         <p:spPr>
           <a:xfrm>
+            <a:off x="2712567" y="1691640"/>
+            <a:ext cx="2377440" cy="2377440"/>
+          </a:xfrm>
+          <a:prstGeom prst="rect">
+            <a:avLst/>
+          </a:prstGeom>
+        </p:spPr>
+      </p:pic>
+      <p:sp>
+        <p:nvSpPr>
+          <p:cNvPr id="8" name="TextBox 7"/>
+          <p:cNvSpPr txBox="1"/>
+          <p:nvPr/>
+        </p:nvSpPr>
+        <p:spPr>
+          <a:xfrm>
+            <a:off x="2255367" y="4233672"/>
+            <a:ext cx="3291840" cy="731520"/>
+          </a:xfrm>
+          <a:prstGeom prst="rect">
+            <a:avLst/>
+          </a:prstGeom>
+          <a:noFill/>
+        </p:spPr>
+        <p:txBody>
+          <a:bodyPr wrap="square" lIns="0" rIns="0" tIns="0" bIns="0">
+            <a:spAutoFit/>
+          </a:bodyPr>
+          <a:lstStyle/>
+          <a:p>
+            <a:pPr algn="ctr">
+              <a:spcAft>
+                <a:spcPts val="0"/>
+              </a:spcAft>
+            </a:pPr>
+            <a:r>
+              <a:rPr sz="2200">
+                <a:solidFill>
+                  <a:srgbClr val="C9CFDC"/>
+                </a:solidFill>
+                <a:latin typeface="Avenir Next"/>
+              </a:rPr>
+              <a:t>pollen</a:t>
+            </a:r>
+          </a:p>
+          <a:p>
+            <a:pPr algn="ctr">
+              <a:spcAft>
+                <a:spcPts val="0"/>
+              </a:spcAft>
+            </a:pPr>
+            <a:r>
+              <a:rPr sz="1800">
+                <a:solidFill>
+                  <a:srgbClr val="00B5FB"/>
+                </a:solidFill>
+                <a:latin typeface="Avenir Next"/>
+              </a:rPr>
+              <a:t>github.com/groupbees/pollen</a:t>
+            </a:r>
+          </a:p>
+        </p:txBody>
+      </p:sp>
+      <p:sp>
+        <p:nvSpPr>
+          <p:cNvPr id="9" name="Rounded Rectangle 8"/>
+          <p:cNvSpPr/>
+          <p:nvPr/>
+        </p:nvSpPr>
+        <p:spPr>
+          <a:xfrm>
+            <a:off x="6991959" y="1581912"/>
+            <a:ext cx="2596896" cy="2596896"/>
+          </a:xfrm>
+          <a:prstGeom prst="roundRect">
+            <a:avLst>
+              <a:gd name="adj" fmla="val 5000"/>
+            </a:avLst>
+          </a:prstGeom>
+          <a:solidFill>
+            <a:srgbClr val="FFFFFF"/>
+          </a:solidFill>
+          <a:ln>
+            <a:noFill/>
+          </a:ln>
+          <a:effectLst/>
+        </p:spPr>
+        <p:style>
+          <a:lnRef idx="1">
+            <a:schemeClr val="accent1"/>
+          </a:lnRef>
+          <a:fillRef idx="3">
+            <a:schemeClr val="accent1"/>
+          </a:fillRef>
+          <a:effectRef idx="2">
+            <a:schemeClr val="accent1"/>
+          </a:effectRef>
+          <a:fontRef idx="minor">
+            <a:schemeClr val="lt1"/>
+          </a:fontRef>
+        </p:style>
+        <p:txBody>
+          <a:bodyPr rtlCol="0" anchor="ctr"/>
+          <a:lstStyle/>
+          <a:p>
+            <a:pPr algn="ctr"/>
+          </a:p>
+        </p:txBody>
+      </p:sp>
+      <p:pic>
+        <p:nvPicPr>
+          <p:cNvPr id="10" name="qr_skills_gitlab.png" descr="qr_skills_gitlab.png"/>
+          <p:cNvPicPr>
+            <a:picLocks noChangeAspect="1"/>
+          </p:cNvPicPr>
+          <p:nvPr/>
+        </p:nvPicPr>
+        <p:blipFill>
+          <a:blip r:embed="rId3"/>
+          <a:stretch>
+            <a:fillRect/>
+          </a:stretch>
+        </p:blipFill>
+        <p:spPr>
+          <a:xfrm>
+            <a:off x="7101687" y="1691640"/>
+            <a:ext cx="2377440" cy="2377440"/>
+          </a:xfrm>
+          <a:prstGeom prst="rect">
+            <a:avLst/>
+          </a:prstGeom>
+        </p:spPr>
+      </p:pic>
+      <p:sp>
+        <p:nvSpPr>
+          <p:cNvPr id="11" name="TextBox 10"/>
+          <p:cNvSpPr txBox="1"/>
+          <p:nvPr/>
+        </p:nvSpPr>
+        <p:spPr>
+          <a:xfrm>
+            <a:off x="6644487" y="4233672"/>
+            <a:ext cx="3291840" cy="731520"/>
+          </a:xfrm>
+          <a:prstGeom prst="rect">
+            <a:avLst/>
+          </a:prstGeom>
+          <a:noFill/>
+        </p:spPr>
+        <p:txBody>
+          <a:bodyPr wrap="square" lIns="0" rIns="0" tIns="0" bIns="0">
+            <a:spAutoFit/>
+          </a:bodyPr>
+          <a:lstStyle/>
+          <a:p>
+            <a:pPr algn="ctr">
+              <a:spcAft>
+                <a:spcPts val="0"/>
+              </a:spcAft>
+            </a:pPr>
+            <a:r>
+              <a:rPr sz="2200">
+                <a:solidFill>
+                  <a:srgbClr val="C9CFDC"/>
+                </a:solidFill>
+                <a:latin typeface="Avenir Next"/>
+              </a:rPr>
+              <a:t>Un catalogue d'exemple</a:t>
+            </a:r>
+          </a:p>
+          <a:p>
+            <a:pPr algn="ctr">
+              <a:spcAft>
+                <a:spcPts val="0"/>
+              </a:spcAft>
+            </a:pPr>
+            <a:r>
+              <a:rPr sz="1800">
+                <a:solidFill>
+                  <a:srgbClr val="00B5FB"/>
+                </a:solidFill>
+                <a:latin typeface="Avenir Next"/>
+              </a:rPr>
+              <a:t>github.com/groupbees/skills-gitlab</a:t>
+            </a:r>
+          </a:p>
+        </p:txBody>
+      </p:sp>
+      <p:sp>
+        <p:nvSpPr>
+          <p:cNvPr id="12" name="TextBox 11"/>
+          <p:cNvSpPr txBox="1"/>
+          <p:nvPr/>
+        </p:nvSpPr>
+        <p:spPr>
+          <a:xfrm>
+            <a:off x="640080" y="5532120"/>
+            <a:ext cx="10881360" cy="457200"/>
+          </a:xfrm>
+          <a:prstGeom prst="rect">
+            <a:avLst/>
+          </a:prstGeom>
+          <a:noFill/>
+        </p:spPr>
+        <p:txBody>
+          <a:bodyPr wrap="square" lIns="0" rIns="0" tIns="0" bIns="0">
+            <a:spAutoFit/>
+          </a:bodyPr>
+          <a:lstStyle/>
+          <a:p>
+            <a:pPr algn="ctr">
+              <a:spcAft>
+                <a:spcPts val="0"/>
+              </a:spcAft>
+            </a:pPr>
+            <a:r>
+              <a:rPr sz="1800">
+                <a:solidFill>
+                  <a:srgbClr val="FFFFFF"/>
+                </a:solidFill>
+                <a:latin typeface="Consolas"/>
+              </a:rPr>
+              <a:t>brew install groupbees/tap/pollen  ·  pip install pollen-skills</a:t>
+            </a:r>
+          </a:p>
+        </p:txBody>
+      </p:sp>
+      <p:pic>
+        <p:nvPicPr>
+          <p:cNvPr id="13" name="logo_light.png" descr="logo_light.png"/>
+          <p:cNvPicPr>
+            <a:picLocks noChangeAspect="1"/>
+          </p:cNvPicPr>
+          <p:nvPr/>
+        </p:nvPicPr>
+        <p:blipFill>
+          <a:blip r:embed="rId5"/>
+          <a:stretch>
+            <a:fillRect/>
+          </a:stretch>
+        </p:blipFill>
+        <p:spPr>
+          <a:xfrm>
             <a:off x="566928" y="6263640"/>
             <a:ext cx="899514" cy="274320"/>
           </a:xfrm>
@@ -28710,7 +29001,7 @@
       </p:pic>
       <p:sp>
         <p:nvSpPr>
-          <p:cNvPr id="9" name="TextBox 8"/>
+          <p:cNvPr id="14" name="TextBox 13"/>
           <p:cNvSpPr txBox="1"/>
           <p:nvPr/>
         </p:nvSpPr>
@@ -28742,7 +29033,7 @@
                 </a:solidFill>
                 <a:latin typeface="Avenir Next"/>
               </a:rPr>
-              <a:t>Industrialiser l'IA en équipe · DevFest Toulouse   ·   31/31</a:t>
+              <a:t>Industrialiser l'IA en équipe · DevFest Toulouse   ·   31/32</a:t>
             </a:r>
           </a:p>
         </p:txBody>
@@ -28764,142 +29055,10 @@
       </p:transition>
     </mc:Fallback>
   </mc:AlternateContent>
-  <p:timing xmlns:mc="http://schemas.openxmlformats.org/markup-compatibility/2006" xmlns:p14="http://schemas.microsoft.com/office/powerpoint/2010/main">
-    <p:tnLst>
-      <p:par>
-        <p:cTn id="1" dur="indefinite" restart="never" nodeType="tmRoot">
-          <p:childTnLst>
-            <p:seq concurrent="1" nextAc="seek">
-              <p:cTn id="2" dur="indefinite" nodeType="mainSeq">
-                <p:childTnLst>
-                  <p:par>
-                    <p:cTn id="3" fill="hold">
-                      <p:stCondLst>
-                        <p:cond delay="indefinite"/>
-                        <p:cond evt="onBegin" delay="0">
-                          <p:tn val="2"/>
-                        </p:cond>
-                      </p:stCondLst>
-                      <p:childTnLst>
-                        <p:par>
-                          <p:cTn id="4" fill="hold">
-                            <p:stCondLst>
-                              <p:cond delay="0"/>
-                            </p:stCondLst>
-                            <p:childTnLst>
-                              <p:par>
-                                <p:cTn id="5" presetID="53" presetClass="entr" presetSubtype="16" fill="hold" nodeType="withEffect">
-                                  <p:stCondLst>
-                                    <p:cond delay="0"/>
-                                  </p:stCondLst>
-                                  <p:childTnLst>
-                                    <p:set>
-                                      <p:cBhvr>
-                                        <p:cTn id="6" dur="1" fill="hold">
-                                          <p:stCondLst>
-                                            <p:cond delay="0"/>
-                                          </p:stCondLst>
-                                        </p:cTn>
-                                        <p:tgtEl>
-                                          <p:spTgt spid="4"/>
-                                        </p:tgtEl>
-                                        <p:attrNameLst>
-                                          <p:attrName>style.visibility</p:attrName>
-                                        </p:attrNameLst>
-                                      </p:cBhvr>
-                                      <p:to>
-                                        <p:strVal val="visible"/>
-                                      </p:to>
-                                    </p:set>
-                                    <p:anim calcmode="lin" valueType="num">
-                                      <p:cBhvr>
-                                        <p:cTn id="7" dur="500" fill="hold"/>
-                                        <p:tgtEl>
-                                          <p:spTgt spid="4"/>
-                                        </p:tgtEl>
-                                        <p:attrNameLst>
-                                          <p:attrName>ppt_w</p:attrName>
-                                        </p:attrNameLst>
-                                      </p:cBhvr>
-                                      <p:tavLst>
-                                        <p:tav tm="0">
-                                          <p:val>
-                                            <p:fltVal val="0"/>
-                                          </p:val>
-                                        </p:tav>
-                                        <p:tav tm="100000">
-                                          <p:val>
-                                            <p:strVal val="#ppt_w"/>
-                                          </p:val>
-                                        </p:tav>
-                                      </p:tavLst>
-                                    </p:anim>
-                                    <p:anim calcmode="lin" valueType="num">
-                                      <p:cBhvr>
-                                        <p:cTn id="8" dur="500" fill="hold"/>
-                                        <p:tgtEl>
-                                          <p:spTgt spid="4"/>
-                                        </p:tgtEl>
-                                        <p:attrNameLst>
-                                          <p:attrName>ppt_h</p:attrName>
-                                        </p:attrNameLst>
-                                      </p:cBhvr>
-                                      <p:tavLst>
-                                        <p:tav tm="0">
-                                          <p:val>
-                                            <p:fltVal val="0"/>
-                                          </p:val>
-                                        </p:tav>
-                                        <p:tav tm="100000">
-                                          <p:val>
-                                            <p:strVal val="#ppt_h"/>
-                                          </p:val>
-                                        </p:tav>
-                                      </p:tavLst>
-                                    </p:anim>
-                                    <p:animEffect transition="in" filter="fade">
-                                      <p:cBhvr>
-                                        <p:cTn id="9" dur="500"/>
-                                        <p:tgtEl>
-                                          <p:spTgt spid="4"/>
-                                        </p:tgtEl>
-                                      </p:cBhvr>
-                                    </p:animEffect>
-                                  </p:childTnLst>
-                                </p:cTn>
-                              </p:par>
-                            </p:childTnLst>
-                          </p:cTn>
-                        </p:par>
-                      </p:childTnLst>
-                    </p:cTn>
-                  </p:par>
-                </p:childTnLst>
-              </p:cTn>
-              <p:prevCondLst>
-                <p:cond evt="onPrev" delay="0">
-                  <p:tgtEl>
-                    <p:sldTgt/>
-                  </p:tgtEl>
-                </p:cond>
-              </p:prevCondLst>
-              <p:nextCondLst>
-                <p:cond evt="onNext" delay="0">
-                  <p:tgtEl>
-                    <p:sldTgt/>
-                  </p:tgtEl>
-                </p:cond>
-              </p:nextCondLst>
-            </p:seq>
-          </p:childTnLst>
-        </p:cTn>
-      </p:par>
-    </p:tnLst>
-  </p:timing>
 </p:sld>
 </file>
 
-<file path=ppt/slides/slide4.xml><?xml version="1.0" encoding="utf-8"?>
+<file path=ppt/slides/slide33.xml><?xml version="1.0" encoding="utf-8"?>
 <p:sld xmlns:a="http://schemas.openxmlformats.org/drawingml/2006/main" xmlns:p="http://schemas.openxmlformats.org/presentationml/2006/main" xmlns:r="http://schemas.openxmlformats.org/officeDocument/2006/relationships">
   <p:cSld>
     <p:spTree>
@@ -28911,20 +29070,20 @@
       <p:grpSpPr/>
       <p:sp>
         <p:nvSpPr>
-          <p:cNvPr id="2" name="Hexagon 1"/>
+          <p:cNvPr id="2" name="Rectangle 1"/>
           <p:cNvSpPr/>
           <p:nvPr/>
         </p:nvSpPr>
         <p:spPr>
           <a:xfrm>
-            <a:off x="10469880" y="1737360"/>
-            <a:ext cx="566928" cy="566928"/>
-          </a:xfrm>
-          <a:prstGeom prst="hexagon">
+            <a:off x="0" y="0"/>
+            <a:ext cx="12191695" cy="6858000"/>
+          </a:xfrm>
+          <a:prstGeom prst="rect">
             <a:avLst/>
           </a:prstGeom>
           <a:solidFill>
-            <a:srgbClr val="EBF6FE"/>
+            <a:srgbClr val="14141A"/>
           </a:solidFill>
           <a:ln>
             <a:noFill/>
@@ -28955,273 +29114,14 @@
       </p:sp>
       <p:sp>
         <p:nvSpPr>
-          <p:cNvPr id="3" name="Hexagon 2"/>
+          <p:cNvPr id="3" name="Rectangle 2"/>
           <p:cNvSpPr/>
           <p:nvPr/>
         </p:nvSpPr>
         <p:spPr>
           <a:xfrm>
-            <a:off x="10957438" y="1737360"/>
-            <a:ext cx="566928" cy="566928"/>
-          </a:xfrm>
-          <a:prstGeom prst="hexagon">
-            <a:avLst/>
-          </a:prstGeom>
-          <a:solidFill>
-            <a:srgbClr val="EBF6FE"/>
-          </a:solidFill>
-          <a:ln>
-            <a:noFill/>
-          </a:ln>
-          <a:effectLst/>
-        </p:spPr>
-        <p:style>
-          <a:lnRef idx="1">
-            <a:schemeClr val="accent1"/>
-          </a:lnRef>
-          <a:fillRef idx="3">
-            <a:schemeClr val="accent1"/>
-          </a:fillRef>
-          <a:effectRef idx="2">
-            <a:schemeClr val="accent1"/>
-          </a:effectRef>
-          <a:fontRef idx="minor">
-            <a:schemeClr val="lt1"/>
-          </a:fontRef>
-        </p:style>
-        <p:txBody>
-          <a:bodyPr rtlCol="0" anchor="ctr"/>
-          <a:lstStyle/>
-          <a:p>
-            <a:pPr algn="ctr"/>
-          </a:p>
-        </p:txBody>
-      </p:sp>
-      <p:sp>
-        <p:nvSpPr>
-          <p:cNvPr id="4" name="Hexagon 3"/>
-          <p:cNvSpPr/>
-          <p:nvPr/>
-        </p:nvSpPr>
-        <p:spPr>
-          <a:xfrm>
-            <a:off x="10713659" y="2162556"/>
-            <a:ext cx="566928" cy="566928"/>
-          </a:xfrm>
-          <a:prstGeom prst="hexagon">
-            <a:avLst/>
-          </a:prstGeom>
-          <a:solidFill>
-            <a:srgbClr val="EBF6FE"/>
-          </a:solidFill>
-          <a:ln>
-            <a:noFill/>
-          </a:ln>
-          <a:effectLst/>
-        </p:spPr>
-        <p:style>
-          <a:lnRef idx="1">
-            <a:schemeClr val="accent1"/>
-          </a:lnRef>
-          <a:fillRef idx="3">
-            <a:schemeClr val="accent1"/>
-          </a:fillRef>
-          <a:effectRef idx="2">
-            <a:schemeClr val="accent1"/>
-          </a:effectRef>
-          <a:fontRef idx="minor">
-            <a:schemeClr val="lt1"/>
-          </a:fontRef>
-        </p:style>
-        <p:txBody>
-          <a:bodyPr rtlCol="0" anchor="ctr"/>
-          <a:lstStyle/>
-          <a:p>
-            <a:pPr algn="ctr"/>
-          </a:p>
-        </p:txBody>
-      </p:sp>
-      <p:sp>
-        <p:nvSpPr>
-          <p:cNvPr id="5" name="Hexagon 4"/>
-          <p:cNvSpPr/>
-          <p:nvPr/>
-        </p:nvSpPr>
-        <p:spPr>
-          <a:xfrm>
-            <a:off x="11201217" y="2162556"/>
-            <a:ext cx="566928" cy="566928"/>
-          </a:xfrm>
-          <a:prstGeom prst="hexagon">
-            <a:avLst/>
-          </a:prstGeom>
-          <a:solidFill>
-            <a:srgbClr val="EBF6FE"/>
-          </a:solidFill>
-          <a:ln>
-            <a:noFill/>
-          </a:ln>
-          <a:effectLst/>
-        </p:spPr>
-        <p:style>
-          <a:lnRef idx="1">
-            <a:schemeClr val="accent1"/>
-          </a:lnRef>
-          <a:fillRef idx="3">
-            <a:schemeClr val="accent1"/>
-          </a:fillRef>
-          <a:effectRef idx="2">
-            <a:schemeClr val="accent1"/>
-          </a:effectRef>
-          <a:fontRef idx="minor">
-            <a:schemeClr val="lt1"/>
-          </a:fontRef>
-        </p:style>
-        <p:txBody>
-          <a:bodyPr rtlCol="0" anchor="ctr"/>
-          <a:lstStyle/>
-          <a:p>
-            <a:pPr algn="ctr"/>
-          </a:p>
-        </p:txBody>
-      </p:sp>
-      <p:sp>
-        <p:nvSpPr>
-          <p:cNvPr id="6" name="Hexagon 5"/>
-          <p:cNvSpPr/>
-          <p:nvPr/>
-        </p:nvSpPr>
-        <p:spPr>
-          <a:xfrm>
-            <a:off x="10469880" y="2587752"/>
-            <a:ext cx="566928" cy="566928"/>
-          </a:xfrm>
-          <a:prstGeom prst="hexagon">
-            <a:avLst/>
-          </a:prstGeom>
-          <a:solidFill>
-            <a:srgbClr val="EBF6FE"/>
-          </a:solidFill>
-          <a:ln>
-            <a:noFill/>
-          </a:ln>
-          <a:effectLst/>
-        </p:spPr>
-        <p:style>
-          <a:lnRef idx="1">
-            <a:schemeClr val="accent1"/>
-          </a:lnRef>
-          <a:fillRef idx="3">
-            <a:schemeClr val="accent1"/>
-          </a:fillRef>
-          <a:effectRef idx="2">
-            <a:schemeClr val="accent1"/>
-          </a:effectRef>
-          <a:fontRef idx="minor">
-            <a:schemeClr val="lt1"/>
-          </a:fontRef>
-        </p:style>
-        <p:txBody>
-          <a:bodyPr rtlCol="0" anchor="ctr"/>
-          <a:lstStyle/>
-          <a:p>
-            <a:pPr algn="ctr"/>
-          </a:p>
-        </p:txBody>
-      </p:sp>
-      <p:sp>
-        <p:nvSpPr>
-          <p:cNvPr id="7" name="Hexagon 6"/>
-          <p:cNvSpPr/>
-          <p:nvPr/>
-        </p:nvSpPr>
-        <p:spPr>
-          <a:xfrm>
-            <a:off x="10957438" y="2587752"/>
-            <a:ext cx="566928" cy="566928"/>
-          </a:xfrm>
-          <a:prstGeom prst="hexagon">
-            <a:avLst/>
-          </a:prstGeom>
-          <a:solidFill>
-            <a:srgbClr val="EBF6FE"/>
-          </a:solidFill>
-          <a:ln>
-            <a:noFill/>
-          </a:ln>
-          <a:effectLst/>
-        </p:spPr>
-        <p:style>
-          <a:lnRef idx="1">
-            <a:schemeClr val="accent1"/>
-          </a:lnRef>
-          <a:fillRef idx="3">
-            <a:schemeClr val="accent1"/>
-          </a:fillRef>
-          <a:effectRef idx="2">
-            <a:schemeClr val="accent1"/>
-          </a:effectRef>
-          <a:fontRef idx="minor">
-            <a:schemeClr val="lt1"/>
-          </a:fontRef>
-        </p:style>
-        <p:txBody>
-          <a:bodyPr rtlCol="0" anchor="ctr"/>
-          <a:lstStyle/>
-          <a:p>
-            <a:pPr algn="ctr"/>
-          </a:p>
-        </p:txBody>
-      </p:sp>
-      <p:sp>
-        <p:nvSpPr>
-          <p:cNvPr id="8" name="TextBox 7"/>
-          <p:cNvSpPr txBox="1"/>
-          <p:nvPr/>
-        </p:nvSpPr>
-        <p:spPr>
-          <a:xfrm>
-            <a:off x="640080" y="457200"/>
-            <a:ext cx="10881360" cy="914400"/>
-          </a:xfrm>
-          <a:prstGeom prst="rect">
-            <a:avLst/>
-          </a:prstGeom>
-          <a:noFill/>
-        </p:spPr>
-        <p:txBody>
-          <a:bodyPr wrap="square" lIns="0" rIns="0" tIns="0" bIns="0">
-            <a:spAutoFit/>
-          </a:bodyPr>
-          <a:lstStyle/>
-          <a:p>
-            <a:pPr algn="l">
-              <a:spcAft>
-                <a:spcPts val="0"/>
-              </a:spcAft>
-            </a:pPr>
-            <a:r>
-              <a:rPr sz="3400" b="1">
-                <a:solidFill>
-                  <a:srgbClr val="14141A"/>
-                </a:solidFill>
-                <a:latin typeface="Avenir Next"/>
-              </a:rPr>
-              <a:t>Le contexte : une plateforme d'API</a:t>
-            </a:r>
-          </a:p>
-        </p:txBody>
-      </p:sp>
-      <p:sp>
-        <p:nvSpPr>
-          <p:cNvPr id="9" name="Rectangle 8"/>
-          <p:cNvSpPr/>
-          <p:nvPr/>
-        </p:nvSpPr>
-        <p:spPr>
-          <a:xfrm>
-            <a:off x="640080" y="1207008"/>
-            <a:ext cx="1371600" cy="73152"/>
+            <a:off x="0" y="0"/>
+            <a:ext cx="12191695" cy="109728"/>
           </a:xfrm>
           <a:prstGeom prst="rect">
             <a:avLst/>
@@ -29264,9 +29164,55 @@
           </a:p>
         </p:txBody>
       </p:sp>
+      <p:sp>
+        <p:nvSpPr>
+          <p:cNvPr id="4" name="Rounded Rectangle 3"/>
+          <p:cNvSpPr/>
+          <p:nvPr/>
+        </p:nvSpPr>
+        <p:spPr>
+          <a:xfrm>
+            <a:off x="8462772" y="2084832"/>
+            <a:ext cx="1591056" cy="1591056"/>
+          </a:xfrm>
+          <a:prstGeom prst="roundRect">
+            <a:avLst>
+              <a:gd name="adj" fmla="val 5000"/>
+            </a:avLst>
+          </a:prstGeom>
+          <a:solidFill>
+            <a:srgbClr val="FFFFFF"/>
+          </a:solidFill>
+          <a:ln>
+            <a:noFill/>
+          </a:ln>
+          <a:effectLst/>
+        </p:spPr>
+        <p:style>
+          <a:lnRef idx="1">
+            <a:schemeClr val="accent1"/>
+          </a:lnRef>
+          <a:fillRef idx="3">
+            <a:schemeClr val="accent1"/>
+          </a:fillRef>
+          <a:effectRef idx="2">
+            <a:schemeClr val="accent1"/>
+          </a:effectRef>
+          <a:fontRef idx="minor">
+            <a:schemeClr val="lt1"/>
+          </a:fontRef>
+        </p:style>
+        <p:txBody>
+          <a:bodyPr rtlCol="0" anchor="ctr"/>
+          <a:lstStyle/>
+          <a:p>
+            <a:pPr algn="ctr"/>
+          </a:p>
+        </p:txBody>
+      </p:sp>
       <p:pic>
         <p:nvPicPr>
-          <p:cNvPr id="10" name="bee_astro.png" descr="bee_astro.png"/>
+          <p:cNvPr id="5" name="qr_linkedin_mazlum.png" descr="qr_linkedin_mazlum.png"/>
           <p:cNvPicPr>
             <a:picLocks noChangeAspect="1"/>
           </p:cNvPicPr>
@@ -29280,6 +29226,772 @@
         </p:blipFill>
         <p:spPr>
           <a:xfrm>
+            <a:off x="8572500" y="2194560"/>
+            <a:ext cx="1371600" cy="1371600"/>
+          </a:xfrm>
+          <a:prstGeom prst="rect">
+            <a:avLst/>
+          </a:prstGeom>
+        </p:spPr>
+      </p:pic>
+      <p:sp>
+        <p:nvSpPr>
+          <p:cNvPr id="6" name="TextBox 5"/>
+          <p:cNvSpPr txBox="1"/>
+          <p:nvPr/>
+        </p:nvSpPr>
+        <p:spPr>
+          <a:xfrm>
+            <a:off x="8115300" y="3730752"/>
+            <a:ext cx="2286000" cy="731520"/>
+          </a:xfrm>
+          <a:prstGeom prst="rect">
+            <a:avLst/>
+          </a:prstGeom>
+          <a:noFill/>
+        </p:spPr>
+        <p:txBody>
+          <a:bodyPr wrap="square" lIns="0" rIns="0" tIns="0" bIns="0">
+            <a:spAutoFit/>
+          </a:bodyPr>
+          <a:lstStyle/>
+          <a:p>
+            <a:pPr algn="ctr">
+              <a:spcAft>
+                <a:spcPts val="0"/>
+              </a:spcAft>
+            </a:pPr>
+            <a:r>
+              <a:rPr sz="1300">
+                <a:solidFill>
+                  <a:srgbClr val="C9CFDC"/>
+                </a:solidFill>
+                <a:latin typeface="Avenir Next"/>
+              </a:rPr>
+              <a:t>Mazlum · LinkedIn</a:t>
+            </a:r>
+          </a:p>
+        </p:txBody>
+      </p:sp>
+      <p:sp>
+        <p:nvSpPr>
+          <p:cNvPr id="7" name="Rounded Rectangle 6"/>
+          <p:cNvSpPr/>
+          <p:nvPr/>
+        </p:nvSpPr>
+        <p:spPr>
+          <a:xfrm>
+            <a:off x="10245852" y="2084832"/>
+            <a:ext cx="1591056" cy="1591056"/>
+          </a:xfrm>
+          <a:prstGeom prst="roundRect">
+            <a:avLst>
+              <a:gd name="adj" fmla="val 5000"/>
+            </a:avLst>
+          </a:prstGeom>
+          <a:solidFill>
+            <a:srgbClr val="FFFFFF"/>
+          </a:solidFill>
+          <a:ln>
+            <a:noFill/>
+          </a:ln>
+          <a:effectLst/>
+        </p:spPr>
+        <p:style>
+          <a:lnRef idx="1">
+            <a:schemeClr val="accent1"/>
+          </a:lnRef>
+          <a:fillRef idx="3">
+            <a:schemeClr val="accent1"/>
+          </a:fillRef>
+          <a:effectRef idx="2">
+            <a:schemeClr val="accent1"/>
+          </a:effectRef>
+          <a:fontRef idx="minor">
+            <a:schemeClr val="lt1"/>
+          </a:fontRef>
+        </p:style>
+        <p:txBody>
+          <a:bodyPr rtlCol="0" anchor="ctr"/>
+          <a:lstStyle/>
+          <a:p>
+            <a:pPr algn="ctr"/>
+          </a:p>
+        </p:txBody>
+      </p:sp>
+      <p:pic>
+        <p:nvPicPr>
+          <p:cNvPr id="8" name="qr_linkedin_guillaume.png" descr="qr_linkedin_guillaume.png"/>
+          <p:cNvPicPr>
+            <a:picLocks noChangeAspect="1"/>
+          </p:cNvPicPr>
+          <p:nvPr/>
+        </p:nvPicPr>
+        <p:blipFill>
+          <a:blip r:embed="rId3"/>
+          <a:stretch>
+            <a:fillRect/>
+          </a:stretch>
+        </p:blipFill>
+        <p:spPr>
+          <a:xfrm>
+            <a:off x="10355580" y="2194560"/>
+            <a:ext cx="1371600" cy="1371600"/>
+          </a:xfrm>
+          <a:prstGeom prst="rect">
+            <a:avLst/>
+          </a:prstGeom>
+        </p:spPr>
+      </p:pic>
+      <p:sp>
+        <p:nvSpPr>
+          <p:cNvPr id="9" name="TextBox 8"/>
+          <p:cNvSpPr txBox="1"/>
+          <p:nvPr/>
+        </p:nvSpPr>
+        <p:spPr>
+          <a:xfrm>
+            <a:off x="9898380" y="3730752"/>
+            <a:ext cx="2286000" cy="731520"/>
+          </a:xfrm>
+          <a:prstGeom prst="rect">
+            <a:avLst/>
+          </a:prstGeom>
+          <a:noFill/>
+        </p:spPr>
+        <p:txBody>
+          <a:bodyPr wrap="square" lIns="0" rIns="0" tIns="0" bIns="0">
+            <a:spAutoFit/>
+          </a:bodyPr>
+          <a:lstStyle/>
+          <a:p>
+            <a:pPr algn="ctr">
+              <a:spcAft>
+                <a:spcPts val="0"/>
+              </a:spcAft>
+            </a:pPr>
+            <a:r>
+              <a:rPr sz="1300">
+                <a:solidFill>
+                  <a:srgbClr val="C9CFDC"/>
+                </a:solidFill>
+                <a:latin typeface="Avenir Next"/>
+              </a:rPr>
+              <a:t>Guillaume · LinkedIn</a:t>
+            </a:r>
+          </a:p>
+        </p:txBody>
+      </p:sp>
+      <p:sp>
+        <p:nvSpPr>
+          <p:cNvPr id="10" name="TextBox 9"/>
+          <p:cNvSpPr txBox="1"/>
+          <p:nvPr/>
+        </p:nvSpPr>
+        <p:spPr>
+          <a:xfrm>
+            <a:off x="640080" y="2194560"/>
+            <a:ext cx="7863840" cy="1280160"/>
+          </a:xfrm>
+          <a:prstGeom prst="rect">
+            <a:avLst/>
+          </a:prstGeom>
+          <a:noFill/>
+        </p:spPr>
+        <p:txBody>
+          <a:bodyPr wrap="square" lIns="0" rIns="0" tIns="0" bIns="0">
+            <a:spAutoFit/>
+          </a:bodyPr>
+          <a:lstStyle/>
+          <a:p>
+            <a:pPr algn="l">
+              <a:spcAft>
+                <a:spcPts val="0"/>
+              </a:spcAft>
+            </a:pPr>
+            <a:r>
+              <a:rPr sz="5400" b="1">
+                <a:solidFill>
+                  <a:srgbClr val="FFFFFF"/>
+                </a:solidFill>
+                <a:latin typeface="Avenir Next"/>
+              </a:rPr>
+              <a:t>Pas par magie.</a:t>
+            </a:r>
+          </a:p>
+        </p:txBody>
+      </p:sp>
+      <p:sp>
+        <p:nvSpPr>
+          <p:cNvPr id="11" name="Rectangle 10"/>
+          <p:cNvSpPr/>
+          <p:nvPr/>
+        </p:nvSpPr>
+        <p:spPr>
+          <a:xfrm>
+            <a:off x="640080" y="3566160"/>
+            <a:ext cx="2194560" cy="91440"/>
+          </a:xfrm>
+          <a:prstGeom prst="rect">
+            <a:avLst/>
+          </a:prstGeom>
+          <a:gradFill rotWithShape="1">
+            <a:gsLst>
+              <a:gs pos="0">
+                <a:srgbClr val="00B5FB"/>
+              </a:gs>
+              <a:gs pos="100000">
+                <a:srgbClr val="974EFF"/>
+              </a:gs>
+            </a:gsLst>
+            <a:lin scaled="0" ang="0"/>
+          </a:gradFill>
+          <a:ln>
+            <a:noFill/>
+          </a:ln>
+          <a:effectLst/>
+        </p:spPr>
+        <p:style>
+          <a:lnRef idx="1">
+            <a:schemeClr val="accent1"/>
+          </a:lnRef>
+          <a:fillRef idx="3">
+            <a:schemeClr val="accent1"/>
+          </a:fillRef>
+          <a:effectRef idx="2">
+            <a:schemeClr val="accent1"/>
+          </a:effectRef>
+          <a:fontRef idx="minor">
+            <a:schemeClr val="lt1"/>
+          </a:fontRef>
+        </p:style>
+        <p:txBody>
+          <a:bodyPr rtlCol="0" anchor="ctr"/>
+          <a:lstStyle/>
+          <a:p>
+            <a:pPr algn="ctr"/>
+          </a:p>
+        </p:txBody>
+      </p:sp>
+      <p:sp>
+        <p:nvSpPr>
+          <p:cNvPr id="12" name="TextBox 11"/>
+          <p:cNvSpPr txBox="1"/>
+          <p:nvPr/>
+        </p:nvSpPr>
+        <p:spPr>
+          <a:xfrm>
+            <a:off x="640080" y="3931920"/>
+            <a:ext cx="7498079" cy="1828800"/>
+          </a:xfrm>
+          <a:prstGeom prst="rect">
+            <a:avLst/>
+          </a:prstGeom>
+          <a:noFill/>
+        </p:spPr>
+        <p:txBody>
+          <a:bodyPr wrap="square" lIns="0" rIns="0" tIns="0" bIns="0">
+            <a:spAutoFit/>
+          </a:bodyPr>
+          <a:lstStyle/>
+          <a:p>
+            <a:pPr algn="l">
+              <a:spcAft>
+                <a:spcPts val="1000"/>
+              </a:spcAft>
+            </a:pPr>
+            <a:r>
+              <a:rPr sz="2000">
+                <a:solidFill>
+                  <a:srgbClr val="C9CFDC"/>
+                </a:solidFill>
+                <a:latin typeface="Avenir Next"/>
+              </a:rPr>
+              <a:t>Parce que les règles sont là.</a:t>
+            </a:r>
+          </a:p>
+          <a:p>
+            <a:pPr algn="l">
+              <a:spcAft>
+                <a:spcPts val="1000"/>
+              </a:spcAft>
+            </a:pPr>
+            <a:r>
+              <a:rPr sz="2000">
+                <a:solidFill>
+                  <a:srgbClr val="C9CFDC"/>
+                </a:solidFill>
+                <a:latin typeface="Avenir Next"/>
+              </a:rPr>
+              <a:t>Merci ! Des questions ?</a:t>
+            </a:r>
+          </a:p>
+        </p:txBody>
+      </p:sp>
+      <p:pic>
+        <p:nvPicPr>
+          <p:cNvPr id="13" name="logo_light.png" descr="logo_light.png"/>
+          <p:cNvPicPr>
+            <a:picLocks noChangeAspect="1"/>
+          </p:cNvPicPr>
+          <p:nvPr/>
+        </p:nvPicPr>
+        <p:blipFill>
+          <a:blip r:embed="rId5"/>
+          <a:stretch>
+            <a:fillRect/>
+          </a:stretch>
+        </p:blipFill>
+        <p:spPr>
+          <a:xfrm>
+            <a:off x="566928" y="6263640"/>
+            <a:ext cx="899514" cy="274320"/>
+          </a:xfrm>
+          <a:prstGeom prst="rect">
+            <a:avLst/>
+          </a:prstGeom>
+        </p:spPr>
+      </p:pic>
+      <p:sp>
+        <p:nvSpPr>
+          <p:cNvPr id="14" name="TextBox 13"/>
+          <p:cNvSpPr txBox="1"/>
+          <p:nvPr/>
+        </p:nvSpPr>
+        <p:spPr>
+          <a:xfrm>
+            <a:off x="6858000" y="6291072"/>
+            <a:ext cx="4754880" cy="320040"/>
+          </a:xfrm>
+          <a:prstGeom prst="rect">
+            <a:avLst/>
+          </a:prstGeom>
+          <a:noFill/>
+        </p:spPr>
+        <p:txBody>
+          <a:bodyPr wrap="square" lIns="0" rIns="0" tIns="0" bIns="0">
+            <a:spAutoFit/>
+          </a:bodyPr>
+          <a:lstStyle/>
+          <a:p>
+            <a:pPr algn="r">
+              <a:spcAft>
+                <a:spcPts val="0"/>
+              </a:spcAft>
+            </a:pPr>
+            <a:r>
+              <a:rPr sz="1100">
+                <a:solidFill>
+                  <a:srgbClr val="C9CFDC"/>
+                </a:solidFill>
+                <a:latin typeface="Avenir Next"/>
+              </a:rPr>
+              <a:t>Industrialiser l'IA en équipe · DevFest Toulouse   ·   32/32</a:t>
+            </a:r>
+          </a:p>
+        </p:txBody>
+      </p:sp>
+    </p:spTree>
+  </p:cSld>
+  <p:clrMapOvr>
+    <a:masterClrMapping/>
+  </p:clrMapOvr>
+  <mc:AlternateContent xmlns:mc="http://schemas.openxmlformats.org/markup-compatibility/2006" xmlns:p14="http://schemas.microsoft.com/office/powerpoint/2010/main">
+    <mc:Choice Requires="p14">
+      <p:transition spd="med" p14:dur="1000">
+        <p14:gallery dir="l"/>
+      </p:transition>
+    </mc:Choice>
+    <mc:Fallback>
+      <p:transition spd="med">
+        <p:fade/>
+      </p:transition>
+    </mc:Fallback>
+  </mc:AlternateContent>
+</p:sld>
+</file>
+
+<file path=ppt/slides/slide4.xml><?xml version="1.0" encoding="utf-8"?>
+<p:sld xmlns:a="http://schemas.openxmlformats.org/drawingml/2006/main" xmlns:p="http://schemas.openxmlformats.org/presentationml/2006/main" xmlns:r="http://schemas.openxmlformats.org/officeDocument/2006/relationships">
+  <p:cSld>
+    <p:spTree>
+      <p:nvGrpSpPr>
+        <p:cNvPr id="1" name=""/>
+        <p:cNvGrpSpPr/>
+        <p:nvPr/>
+      </p:nvGrpSpPr>
+      <p:grpSpPr/>
+      <p:sp>
+        <p:nvSpPr>
+          <p:cNvPr id="2" name="Hexagon 1"/>
+          <p:cNvSpPr/>
+          <p:nvPr/>
+        </p:nvSpPr>
+        <p:spPr>
+          <a:xfrm>
+            <a:off x="10469880" y="1737360"/>
+            <a:ext cx="566928" cy="566928"/>
+          </a:xfrm>
+          <a:prstGeom prst="hexagon">
+            <a:avLst/>
+          </a:prstGeom>
+          <a:solidFill>
+            <a:srgbClr val="EBF6FE"/>
+          </a:solidFill>
+          <a:ln>
+            <a:noFill/>
+          </a:ln>
+          <a:effectLst/>
+        </p:spPr>
+        <p:style>
+          <a:lnRef idx="1">
+            <a:schemeClr val="accent1"/>
+          </a:lnRef>
+          <a:fillRef idx="3">
+            <a:schemeClr val="accent1"/>
+          </a:fillRef>
+          <a:effectRef idx="2">
+            <a:schemeClr val="accent1"/>
+          </a:effectRef>
+          <a:fontRef idx="minor">
+            <a:schemeClr val="lt1"/>
+          </a:fontRef>
+        </p:style>
+        <p:txBody>
+          <a:bodyPr rtlCol="0" anchor="ctr"/>
+          <a:lstStyle/>
+          <a:p>
+            <a:pPr algn="ctr"/>
+          </a:p>
+        </p:txBody>
+      </p:sp>
+      <p:sp>
+        <p:nvSpPr>
+          <p:cNvPr id="3" name="Hexagon 2"/>
+          <p:cNvSpPr/>
+          <p:nvPr/>
+        </p:nvSpPr>
+        <p:spPr>
+          <a:xfrm>
+            <a:off x="10957438" y="1737360"/>
+            <a:ext cx="566928" cy="566928"/>
+          </a:xfrm>
+          <a:prstGeom prst="hexagon">
+            <a:avLst/>
+          </a:prstGeom>
+          <a:solidFill>
+            <a:srgbClr val="EBF6FE"/>
+          </a:solidFill>
+          <a:ln>
+            <a:noFill/>
+          </a:ln>
+          <a:effectLst/>
+        </p:spPr>
+        <p:style>
+          <a:lnRef idx="1">
+            <a:schemeClr val="accent1"/>
+          </a:lnRef>
+          <a:fillRef idx="3">
+            <a:schemeClr val="accent1"/>
+          </a:fillRef>
+          <a:effectRef idx="2">
+            <a:schemeClr val="accent1"/>
+          </a:effectRef>
+          <a:fontRef idx="minor">
+            <a:schemeClr val="lt1"/>
+          </a:fontRef>
+        </p:style>
+        <p:txBody>
+          <a:bodyPr rtlCol="0" anchor="ctr"/>
+          <a:lstStyle/>
+          <a:p>
+            <a:pPr algn="ctr"/>
+          </a:p>
+        </p:txBody>
+      </p:sp>
+      <p:sp>
+        <p:nvSpPr>
+          <p:cNvPr id="4" name="Hexagon 3"/>
+          <p:cNvSpPr/>
+          <p:nvPr/>
+        </p:nvSpPr>
+        <p:spPr>
+          <a:xfrm>
+            <a:off x="10713659" y="2162556"/>
+            <a:ext cx="566928" cy="566928"/>
+          </a:xfrm>
+          <a:prstGeom prst="hexagon">
+            <a:avLst/>
+          </a:prstGeom>
+          <a:solidFill>
+            <a:srgbClr val="EBF6FE"/>
+          </a:solidFill>
+          <a:ln>
+            <a:noFill/>
+          </a:ln>
+          <a:effectLst/>
+        </p:spPr>
+        <p:style>
+          <a:lnRef idx="1">
+            <a:schemeClr val="accent1"/>
+          </a:lnRef>
+          <a:fillRef idx="3">
+            <a:schemeClr val="accent1"/>
+          </a:fillRef>
+          <a:effectRef idx="2">
+            <a:schemeClr val="accent1"/>
+          </a:effectRef>
+          <a:fontRef idx="minor">
+            <a:schemeClr val="lt1"/>
+          </a:fontRef>
+        </p:style>
+        <p:txBody>
+          <a:bodyPr rtlCol="0" anchor="ctr"/>
+          <a:lstStyle/>
+          <a:p>
+            <a:pPr algn="ctr"/>
+          </a:p>
+        </p:txBody>
+      </p:sp>
+      <p:sp>
+        <p:nvSpPr>
+          <p:cNvPr id="5" name="Hexagon 4"/>
+          <p:cNvSpPr/>
+          <p:nvPr/>
+        </p:nvSpPr>
+        <p:spPr>
+          <a:xfrm>
+            <a:off x="11201217" y="2162556"/>
+            <a:ext cx="566928" cy="566928"/>
+          </a:xfrm>
+          <a:prstGeom prst="hexagon">
+            <a:avLst/>
+          </a:prstGeom>
+          <a:solidFill>
+            <a:srgbClr val="EBF6FE"/>
+          </a:solidFill>
+          <a:ln>
+            <a:noFill/>
+          </a:ln>
+          <a:effectLst/>
+        </p:spPr>
+        <p:style>
+          <a:lnRef idx="1">
+            <a:schemeClr val="accent1"/>
+          </a:lnRef>
+          <a:fillRef idx="3">
+            <a:schemeClr val="accent1"/>
+          </a:fillRef>
+          <a:effectRef idx="2">
+            <a:schemeClr val="accent1"/>
+          </a:effectRef>
+          <a:fontRef idx="minor">
+            <a:schemeClr val="lt1"/>
+          </a:fontRef>
+        </p:style>
+        <p:txBody>
+          <a:bodyPr rtlCol="0" anchor="ctr"/>
+          <a:lstStyle/>
+          <a:p>
+            <a:pPr algn="ctr"/>
+          </a:p>
+        </p:txBody>
+      </p:sp>
+      <p:sp>
+        <p:nvSpPr>
+          <p:cNvPr id="6" name="Hexagon 5"/>
+          <p:cNvSpPr/>
+          <p:nvPr/>
+        </p:nvSpPr>
+        <p:spPr>
+          <a:xfrm>
+            <a:off x="10469880" y="2587752"/>
+            <a:ext cx="566928" cy="566928"/>
+          </a:xfrm>
+          <a:prstGeom prst="hexagon">
+            <a:avLst/>
+          </a:prstGeom>
+          <a:solidFill>
+            <a:srgbClr val="EBF6FE"/>
+          </a:solidFill>
+          <a:ln>
+            <a:noFill/>
+          </a:ln>
+          <a:effectLst/>
+        </p:spPr>
+        <p:style>
+          <a:lnRef idx="1">
+            <a:schemeClr val="accent1"/>
+          </a:lnRef>
+          <a:fillRef idx="3">
+            <a:schemeClr val="accent1"/>
+          </a:fillRef>
+          <a:effectRef idx="2">
+            <a:schemeClr val="accent1"/>
+          </a:effectRef>
+          <a:fontRef idx="minor">
+            <a:schemeClr val="lt1"/>
+          </a:fontRef>
+        </p:style>
+        <p:txBody>
+          <a:bodyPr rtlCol="0" anchor="ctr"/>
+          <a:lstStyle/>
+          <a:p>
+            <a:pPr algn="ctr"/>
+          </a:p>
+        </p:txBody>
+      </p:sp>
+      <p:sp>
+        <p:nvSpPr>
+          <p:cNvPr id="7" name="Hexagon 6"/>
+          <p:cNvSpPr/>
+          <p:nvPr/>
+        </p:nvSpPr>
+        <p:spPr>
+          <a:xfrm>
+            <a:off x="10957438" y="2587752"/>
+            <a:ext cx="566928" cy="566928"/>
+          </a:xfrm>
+          <a:prstGeom prst="hexagon">
+            <a:avLst/>
+          </a:prstGeom>
+          <a:solidFill>
+            <a:srgbClr val="EBF6FE"/>
+          </a:solidFill>
+          <a:ln>
+            <a:noFill/>
+          </a:ln>
+          <a:effectLst/>
+        </p:spPr>
+        <p:style>
+          <a:lnRef idx="1">
+            <a:schemeClr val="accent1"/>
+          </a:lnRef>
+          <a:fillRef idx="3">
+            <a:schemeClr val="accent1"/>
+          </a:fillRef>
+          <a:effectRef idx="2">
+            <a:schemeClr val="accent1"/>
+          </a:effectRef>
+          <a:fontRef idx="minor">
+            <a:schemeClr val="lt1"/>
+          </a:fontRef>
+        </p:style>
+        <p:txBody>
+          <a:bodyPr rtlCol="0" anchor="ctr"/>
+          <a:lstStyle/>
+          <a:p>
+            <a:pPr algn="ctr"/>
+          </a:p>
+        </p:txBody>
+      </p:sp>
+      <p:sp>
+        <p:nvSpPr>
+          <p:cNvPr id="8" name="TextBox 7"/>
+          <p:cNvSpPr txBox="1"/>
+          <p:nvPr/>
+        </p:nvSpPr>
+        <p:spPr>
+          <a:xfrm>
+            <a:off x="640080" y="457200"/>
+            <a:ext cx="10881360" cy="914400"/>
+          </a:xfrm>
+          <a:prstGeom prst="rect">
+            <a:avLst/>
+          </a:prstGeom>
+          <a:noFill/>
+        </p:spPr>
+        <p:txBody>
+          <a:bodyPr wrap="square" lIns="0" rIns="0" tIns="0" bIns="0">
+            <a:spAutoFit/>
+          </a:bodyPr>
+          <a:lstStyle/>
+          <a:p>
+            <a:pPr algn="l">
+              <a:spcAft>
+                <a:spcPts val="0"/>
+              </a:spcAft>
+            </a:pPr>
+            <a:r>
+              <a:rPr sz="3400" b="1">
+                <a:solidFill>
+                  <a:srgbClr val="14141A"/>
+                </a:solidFill>
+                <a:latin typeface="Avenir Next"/>
+              </a:rPr>
+              <a:t>Le contexte : une plateforme d'API</a:t>
+            </a:r>
+          </a:p>
+        </p:txBody>
+      </p:sp>
+      <p:sp>
+        <p:nvSpPr>
+          <p:cNvPr id="9" name="Rectangle 8"/>
+          <p:cNvSpPr/>
+          <p:nvPr/>
+        </p:nvSpPr>
+        <p:spPr>
+          <a:xfrm>
+            <a:off x="640080" y="1207008"/>
+            <a:ext cx="1371600" cy="73152"/>
+          </a:xfrm>
+          <a:prstGeom prst="rect">
+            <a:avLst/>
+          </a:prstGeom>
+          <a:gradFill rotWithShape="1">
+            <a:gsLst>
+              <a:gs pos="0">
+                <a:srgbClr val="00B5FB"/>
+              </a:gs>
+              <a:gs pos="100000">
+                <a:srgbClr val="974EFF"/>
+              </a:gs>
+            </a:gsLst>
+            <a:lin scaled="0" ang="0"/>
+          </a:gradFill>
+          <a:ln>
+            <a:noFill/>
+          </a:ln>
+          <a:effectLst/>
+        </p:spPr>
+        <p:style>
+          <a:lnRef idx="1">
+            <a:schemeClr val="accent1"/>
+          </a:lnRef>
+          <a:fillRef idx="3">
+            <a:schemeClr val="accent1"/>
+          </a:fillRef>
+          <a:effectRef idx="2">
+            <a:schemeClr val="accent1"/>
+          </a:effectRef>
+          <a:fontRef idx="minor">
+            <a:schemeClr val="lt1"/>
+          </a:fontRef>
+        </p:style>
+        <p:txBody>
+          <a:bodyPr rtlCol="0" anchor="ctr"/>
+          <a:lstStyle/>
+          <a:p>
+            <a:pPr algn="ctr"/>
+          </a:p>
+        </p:txBody>
+      </p:sp>
+      <p:pic>
+        <p:nvPicPr>
+          <p:cNvPr id="10" name="bee_astro.png" descr="bee_astro.png"/>
+          <p:cNvPicPr>
+            <a:picLocks noChangeAspect="1"/>
+          </p:cNvPicPr>
+          <p:nvPr/>
+        </p:nvPicPr>
+        <p:blipFill>
+          <a:blip r:embed="rId2"/>
+          <a:stretch>
+            <a:fillRect/>
+          </a:stretch>
+        </p:blipFill>
+        <p:spPr>
+          <a:xfrm>
             <a:off x="8778240" y="2011680"/>
             <a:ext cx="2347625" cy="2926080"/>
           </a:xfrm>
@@ -29761,7 +30473,7 @@
                 </a:solidFill>
                 <a:latin typeface="Avenir Next"/>
               </a:rPr>
-              <a:t>Industrialiser l'IA en équipe · DevFest Toulouse   ·   3/31</a:t>
+              <a:t>Industrialiser l'IA en équipe · DevFest Toulouse   ·   3/32</a:t>
             </a:r>
           </a:p>
         </p:txBody>
@@ -30788,7 +31500,7 @@
                 </a:solidFill>
                 <a:latin typeface="Avenir Next"/>
               </a:rPr>
-              <a:t>Industrialiser l'IA en équipe · DevFest Toulouse   ·   4/31</a:t>
+              <a:t>Industrialiser l'IA en équipe · DevFest Toulouse   ·   4/32</a:t>
             </a:r>
           </a:p>
         </p:txBody>
@@ -31815,7 +32527,7 @@
                 </a:solidFill>
                 <a:latin typeface="Avenir Next"/>
               </a:rPr>
-              <a:t>Industrialiser l'IA en équipe · DevFest Toulouse   ·   5/31</a:t>
+              <a:t>Industrialiser l'IA en équipe · DevFest Toulouse   ·   5/32</a:t>
             </a:r>
           </a:p>
         </p:txBody>
@@ -32916,7 +33628,7 @@
                 </a:solidFill>
                 <a:latin typeface="Avenir Next"/>
               </a:rPr>
-              <a:t>Industrialiser l'IA en équipe · DevFest Toulouse   ·   6/31</a:t>
+              <a:t>Industrialiser l'IA en équipe · DevFest Toulouse   ·   6/32</a:t>
             </a:r>
           </a:p>
         </p:txBody>
@@ -34026,7 +34738,7 @@
                 </a:solidFill>
                 <a:latin typeface="Avenir Next"/>
               </a:rPr>
-              <a:t>Industrialiser l'IA en équipe · DevFest Toulouse   ·   7/31</a:t>
+              <a:t>Industrialiser l'IA en équipe · DevFest Toulouse   ·   7/32</a:t>
             </a:r>
           </a:p>
         </p:txBody>
@@ -35125,7 +35837,7 @@
                 </a:solidFill>
                 <a:latin typeface="Avenir Next"/>
               </a:rPr>
-              <a:t>Industrialiser l'IA en équipe · DevFest Toulouse   ·   8/31</a:t>
+              <a:t>Industrialiser l'IA en équipe · DevFest Toulouse   ·   8/32</a:t>
             </a:r>
           </a:p>
         </p:txBody>

</xml_diff>

<commit_message>
Slide « Essayez-le » : QR vers tosun-si/skills-core, nos skills en public
skills-gitlab cède la place au skills-core de la démo, publié sur
le compte de Mazlum (v0.4.0, nettoyé des noms internes).
</commit_message>
<xml_diff>
--- a/talks/slides/talk_devfest_skills.pptx
+++ b/talks/slides/talk_devfest_skills.pptx
@@ -2924,7 +2924,7 @@
           </a:p>
           <a:p>
             <a:r>
-              <a:t>• « De quoi l'essayer ce soir : pollen, et un catalogue public rangé par domaines »</a:t>
+              <a:t>• « De quoi l'essayer ce soir : pollen, et nos skills de la démo, en public »</a:t>
             </a:r>
           </a:p>
           <a:p>
@@ -2945,7 +2945,7 @@
           </a:p>
           <a:p>
             <a:r>
-              <a:t>De quoi l'essayer ce soir. pollen, et un catalogue public rangé par domaines, comme celui de la démo : le pollen.yaml du README marche tel quel.</a:t>
+              <a:t>De quoi l'essayer ce soir. pollen, et nos skills en public : le skills-core de la démo, rangé par domaines. Le pollen.yaml du README marche tel quel.</a:t>
             </a:r>
           </a:p>
         </p:txBody>
@@ -28859,7 +28859,7 @@
       </p:sp>
       <p:pic>
         <p:nvPicPr>
-          <p:cNvPr id="10" name="qr_skills_gitlab.png" descr="qr_skills_gitlab.png"/>
+          <p:cNvPr id="10" name="qr_skills_core.png" descr="qr_skills_core.png"/>
           <p:cNvPicPr>
             <a:picLocks noChangeAspect="1"/>
           </p:cNvPicPr>
@@ -28915,7 +28915,7 @@
                 </a:solidFill>
                 <a:latin typeface="Avenir Next"/>
               </a:rPr>
-              <a:t>Un catalogue d'exemple</a:t>
+              <a:t>Nos skills, en public</a:t>
             </a:r>
           </a:p>
           <a:p>
@@ -28931,7 +28931,7 @@
                 </a:solidFill>
                 <a:latin typeface="Avenir Next"/>
               </a:rPr>
-              <a:t>github.com/groupbees/skills-gitlab</a:t>
+              <a:t>github.com/tosun-si/skills-core</a:t>
             </a:r>
           </a:p>
         </p:txBody>

</xml_diff>